<commit_message>
Add change for remove Document version column form code
</commit_message>
<xml_diff>
--- a/release/assets/DMS_AdobeSign_Guide.pptx
+++ b/release/assets/DMS_AdobeSign_Guide.pptx
@@ -5,16 +5,15 @@
     <p:sldMasterId id="2147483648" r:id="rId1"/>
   </p:sldMasterIdLst>
   <p:sldIdLst>
-    <p:sldId id="256" r:id="rId7"/>
-    <p:sldId id="257" r:id="rId8"/>
-    <p:sldId id="258" r:id="rId9"/>
-    <p:sldId id="259" r:id="rId10"/>
-    <p:sldId id="260" r:id="rId11"/>
-    <p:sldId id="261" r:id="rId12"/>
-    <p:sldId id="262" r:id="rId13"/>
-    <p:sldId id="263" r:id="rId14"/>
+    <p:sldId id="256" r:id="rId2"/>
+    <p:sldId id="257" r:id="rId3"/>
+    <p:sldId id="259" r:id="rId4"/>
+    <p:sldId id="260" r:id="rId5"/>
+    <p:sldId id="261" r:id="rId6"/>
+    <p:sldId id="262" r:id="rId7"/>
+    <p:sldId id="263" r:id="rId8"/>
   </p:sldIdLst>
-  <p:sldSz cx="12188952" cy="6858000" type="screen4x3"/>
+  <p:sldSz cx="12188825" cy="6858000"/>
   <p:notesSz cx="6858000" cy="9144000"/>
   <p:defaultTextStyle>
     <a:defPPr>
@@ -111,6 +110,22 @@
       </a:defRPr>
     </a:lvl9pPr>
   </p:defaultTextStyle>
+  <p:extLst>
+    <p:ext uri="{EFAFB233-063F-42B5-8137-9DF3F51BA10A}">
+      <p15:sldGuideLst xmlns:p15="http://schemas.microsoft.com/office/powerpoint/2012/main">
+        <p15:guide id="1" orient="horz" pos="2160">
+          <p15:clr>
+            <a:srgbClr val="A4A3A4"/>
+          </p15:clr>
+        </p15:guide>
+        <p15:guide id="2" pos="2880">
+          <p15:clr>
+            <a:srgbClr val="A4A3A4"/>
+          </p15:clr>
+        </p15:guide>
+      </p15:sldGuideLst>
+    </p:ext>
+  </p:extLst>
 </p:presentation>
 </file>
 
@@ -152,10 +167,9 @@
           <a:lstStyle/>
           <a:p>
             <a:r>
-              <a:rPr lang="en-US" smtClean="0"/>
+              <a:rPr lang="en-US"/>
               <a:t>Click to edit Master title style</a:t>
             </a:r>
-            <a:endParaRPr lang="en-US"/>
           </a:p>
         </p:txBody>
       </p:sp>
@@ -271,10 +285,9 @@
           </a:lstStyle>
           <a:p>
             <a:r>
-              <a:rPr lang="en-US" smtClean="0"/>
+              <a:rPr lang="en-US"/>
               <a:t>Click to edit Master subtitle style</a:t>
             </a:r>
-            <a:endParaRPr lang="en-US"/>
           </a:p>
         </p:txBody>
       </p:sp>
@@ -295,7 +308,7 @@
           <a:p>
             <a:fld id="{5BCAD085-E8A6-8845-BD4E-CB4CCA059FC4}" type="datetimeFigureOut">
               <a:rPr lang="en-US" smtClean="0"/>
-              <a:t>1/27/13</a:t>
+              <a:t>3/18/2026</a:t>
             </a:fld>
             <a:endParaRPr lang="en-US"/>
           </a:p>
@@ -389,10 +402,9 @@
           <a:lstStyle/>
           <a:p>
             <a:r>
-              <a:rPr lang="en-US" smtClean="0"/>
+              <a:rPr lang="en-US"/>
               <a:t>Click to edit Master title style</a:t>
             </a:r>
-            <a:endParaRPr lang="en-US"/>
           </a:p>
         </p:txBody>
       </p:sp>
@@ -413,38 +425,37 @@
           <a:p>
             <a:pPr lvl="0"/>
             <a:r>
-              <a:rPr lang="en-US" smtClean="0"/>
+              <a:rPr lang="en-US"/>
               <a:t>Click to edit Master text styles</a:t>
             </a:r>
           </a:p>
           <a:p>
             <a:pPr lvl="1"/>
             <a:r>
-              <a:rPr lang="en-US" smtClean="0"/>
+              <a:rPr lang="en-US"/>
               <a:t>Second level</a:t>
             </a:r>
           </a:p>
           <a:p>
             <a:pPr lvl="2"/>
             <a:r>
-              <a:rPr lang="en-US" smtClean="0"/>
+              <a:rPr lang="en-US"/>
               <a:t>Third level</a:t>
             </a:r>
           </a:p>
           <a:p>
             <a:pPr lvl="3"/>
             <a:r>
-              <a:rPr lang="en-US" smtClean="0"/>
+              <a:rPr lang="en-US"/>
               <a:t>Fourth level</a:t>
             </a:r>
           </a:p>
           <a:p>
             <a:pPr lvl="4"/>
             <a:r>
-              <a:rPr lang="en-US" smtClean="0"/>
+              <a:rPr lang="en-US"/>
               <a:t>Fifth level</a:t>
             </a:r>
-            <a:endParaRPr lang="en-US"/>
           </a:p>
         </p:txBody>
       </p:sp>
@@ -465,7 +476,7 @@
           <a:p>
             <a:fld id="{5BCAD085-E8A6-8845-BD4E-CB4CCA059FC4}" type="datetimeFigureOut">
               <a:rPr lang="en-US" smtClean="0"/>
-              <a:t>1/27/13</a:t>
+              <a:t>3/18/2026</a:t>
             </a:fld>
             <a:endParaRPr lang="en-US"/>
           </a:p>
@@ -564,10 +575,9 @@
           <a:lstStyle/>
           <a:p>
             <a:r>
-              <a:rPr lang="en-US" smtClean="0"/>
+              <a:rPr lang="en-US"/>
               <a:t>Click to edit Master title style</a:t>
             </a:r>
-            <a:endParaRPr lang="en-US"/>
           </a:p>
         </p:txBody>
       </p:sp>
@@ -593,38 +603,37 @@
           <a:p>
             <a:pPr lvl="0"/>
             <a:r>
-              <a:rPr lang="en-US" smtClean="0"/>
+              <a:rPr lang="en-US"/>
               <a:t>Click to edit Master text styles</a:t>
             </a:r>
           </a:p>
           <a:p>
             <a:pPr lvl="1"/>
             <a:r>
-              <a:rPr lang="en-US" smtClean="0"/>
+              <a:rPr lang="en-US"/>
               <a:t>Second level</a:t>
             </a:r>
           </a:p>
           <a:p>
             <a:pPr lvl="2"/>
             <a:r>
-              <a:rPr lang="en-US" smtClean="0"/>
+              <a:rPr lang="en-US"/>
               <a:t>Third level</a:t>
             </a:r>
           </a:p>
           <a:p>
             <a:pPr lvl="3"/>
             <a:r>
-              <a:rPr lang="en-US" smtClean="0"/>
+              <a:rPr lang="en-US"/>
               <a:t>Fourth level</a:t>
             </a:r>
           </a:p>
           <a:p>
             <a:pPr lvl="4"/>
             <a:r>
-              <a:rPr lang="en-US" smtClean="0"/>
+              <a:rPr lang="en-US"/>
               <a:t>Fifth level</a:t>
             </a:r>
-            <a:endParaRPr lang="en-US"/>
           </a:p>
         </p:txBody>
       </p:sp>
@@ -645,7 +654,7 @@
           <a:p>
             <a:fld id="{5BCAD085-E8A6-8845-BD4E-CB4CCA059FC4}" type="datetimeFigureOut">
               <a:rPr lang="en-US" smtClean="0"/>
-              <a:t>1/27/13</a:t>
+              <a:t>3/18/2026</a:t>
             </a:fld>
             <a:endParaRPr lang="en-US"/>
           </a:p>
@@ -739,10 +748,9 @@
           <a:lstStyle/>
           <a:p>
             <a:r>
-              <a:rPr lang="en-US" smtClean="0"/>
+              <a:rPr lang="en-US"/>
               <a:t>Click to edit Master title style</a:t>
             </a:r>
-            <a:endParaRPr lang="en-US"/>
           </a:p>
         </p:txBody>
       </p:sp>
@@ -763,38 +771,37 @@
           <a:p>
             <a:pPr lvl="0"/>
             <a:r>
-              <a:rPr lang="en-US" smtClean="0"/>
+              <a:rPr lang="en-US"/>
               <a:t>Click to edit Master text styles</a:t>
             </a:r>
           </a:p>
           <a:p>
             <a:pPr lvl="1"/>
             <a:r>
-              <a:rPr lang="en-US" smtClean="0"/>
+              <a:rPr lang="en-US"/>
               <a:t>Second level</a:t>
             </a:r>
           </a:p>
           <a:p>
             <a:pPr lvl="2"/>
             <a:r>
-              <a:rPr lang="en-US" smtClean="0"/>
+              <a:rPr lang="en-US"/>
               <a:t>Third level</a:t>
             </a:r>
           </a:p>
           <a:p>
             <a:pPr lvl="3"/>
             <a:r>
-              <a:rPr lang="en-US" smtClean="0"/>
+              <a:rPr lang="en-US"/>
               <a:t>Fourth level</a:t>
             </a:r>
           </a:p>
           <a:p>
             <a:pPr lvl="4"/>
             <a:r>
-              <a:rPr lang="en-US" smtClean="0"/>
+              <a:rPr lang="en-US"/>
               <a:t>Fifth level</a:t>
             </a:r>
-            <a:endParaRPr lang="en-US"/>
           </a:p>
         </p:txBody>
       </p:sp>
@@ -815,7 +822,7 @@
           <a:p>
             <a:fld id="{5BCAD085-E8A6-8845-BD4E-CB4CCA059FC4}" type="datetimeFigureOut">
               <a:rPr lang="en-US" smtClean="0"/>
-              <a:t>1/27/13</a:t>
+              <a:t>3/18/2026</a:t>
             </a:fld>
             <a:endParaRPr lang="en-US"/>
           </a:p>
@@ -918,10 +925,9 @@
           </a:lstStyle>
           <a:p>
             <a:r>
-              <a:rPr lang="en-US" smtClean="0"/>
+              <a:rPr lang="en-US"/>
               <a:t>Click to edit Master title style</a:t>
             </a:r>
-            <a:endParaRPr lang="en-US"/>
           </a:p>
         </p:txBody>
       </p:sp>
@@ -1038,7 +1044,7 @@
           <a:p>
             <a:pPr lvl="0"/>
             <a:r>
-              <a:rPr lang="en-US" smtClean="0"/>
+              <a:rPr lang="en-US"/>
               <a:t>Click to edit Master text styles</a:t>
             </a:r>
           </a:p>
@@ -1061,7 +1067,7 @@
           <a:p>
             <a:fld id="{5BCAD085-E8A6-8845-BD4E-CB4CCA059FC4}" type="datetimeFigureOut">
               <a:rPr lang="en-US" smtClean="0"/>
-              <a:t>1/27/13</a:t>
+              <a:t>3/18/2026</a:t>
             </a:fld>
             <a:endParaRPr lang="en-US"/>
           </a:p>
@@ -1155,10 +1161,9 @@
           <a:lstStyle/>
           <a:p>
             <a:r>
-              <a:rPr lang="en-US" smtClean="0"/>
+              <a:rPr lang="en-US"/>
               <a:t>Click to edit Master title style</a:t>
             </a:r>
-            <a:endParaRPr lang="en-US"/>
           </a:p>
         </p:txBody>
       </p:sp>
@@ -1212,38 +1217,37 @@
           <a:p>
             <a:pPr lvl="0"/>
             <a:r>
-              <a:rPr lang="en-US" smtClean="0"/>
+              <a:rPr lang="en-US"/>
               <a:t>Click to edit Master text styles</a:t>
             </a:r>
           </a:p>
           <a:p>
             <a:pPr lvl="1"/>
             <a:r>
-              <a:rPr lang="en-US" smtClean="0"/>
+              <a:rPr lang="en-US"/>
               <a:t>Second level</a:t>
             </a:r>
           </a:p>
           <a:p>
             <a:pPr lvl="2"/>
             <a:r>
-              <a:rPr lang="en-US" smtClean="0"/>
+              <a:rPr lang="en-US"/>
               <a:t>Third level</a:t>
             </a:r>
           </a:p>
           <a:p>
             <a:pPr lvl="3"/>
             <a:r>
-              <a:rPr lang="en-US" smtClean="0"/>
+              <a:rPr lang="en-US"/>
               <a:t>Fourth level</a:t>
             </a:r>
           </a:p>
           <a:p>
             <a:pPr lvl="4"/>
             <a:r>
-              <a:rPr lang="en-US" smtClean="0"/>
+              <a:rPr lang="en-US"/>
               <a:t>Fifth level</a:t>
             </a:r>
-            <a:endParaRPr lang="en-US"/>
           </a:p>
         </p:txBody>
       </p:sp>
@@ -1297,38 +1301,37 @@
           <a:p>
             <a:pPr lvl="0"/>
             <a:r>
-              <a:rPr lang="en-US" smtClean="0"/>
+              <a:rPr lang="en-US"/>
               <a:t>Click to edit Master text styles</a:t>
             </a:r>
           </a:p>
           <a:p>
             <a:pPr lvl="1"/>
             <a:r>
-              <a:rPr lang="en-US" smtClean="0"/>
+              <a:rPr lang="en-US"/>
               <a:t>Second level</a:t>
             </a:r>
           </a:p>
           <a:p>
             <a:pPr lvl="2"/>
             <a:r>
-              <a:rPr lang="en-US" smtClean="0"/>
+              <a:rPr lang="en-US"/>
               <a:t>Third level</a:t>
             </a:r>
           </a:p>
           <a:p>
             <a:pPr lvl="3"/>
             <a:r>
-              <a:rPr lang="en-US" smtClean="0"/>
+              <a:rPr lang="en-US"/>
               <a:t>Fourth level</a:t>
             </a:r>
           </a:p>
           <a:p>
             <a:pPr lvl="4"/>
             <a:r>
-              <a:rPr lang="en-US" smtClean="0"/>
+              <a:rPr lang="en-US"/>
               <a:t>Fifth level</a:t>
             </a:r>
-            <a:endParaRPr lang="en-US"/>
           </a:p>
         </p:txBody>
       </p:sp>
@@ -1349,7 +1352,7 @@
           <a:p>
             <a:fld id="{5BCAD085-E8A6-8845-BD4E-CB4CCA059FC4}" type="datetimeFigureOut">
               <a:rPr lang="en-US" smtClean="0"/>
-              <a:t>1/27/13</a:t>
+              <a:t>3/18/2026</a:t>
             </a:fld>
             <a:endParaRPr lang="en-US"/>
           </a:p>
@@ -1447,10 +1450,9 @@
           </a:lstStyle>
           <a:p>
             <a:r>
-              <a:rPr lang="en-US" smtClean="0"/>
+              <a:rPr lang="en-US"/>
               <a:t>Click to edit Master title style</a:t>
             </a:r>
-            <a:endParaRPr lang="en-US"/>
           </a:p>
         </p:txBody>
       </p:sp>
@@ -1513,7 +1515,7 @@
           <a:p>
             <a:pPr lvl="0"/>
             <a:r>
-              <a:rPr lang="en-US" smtClean="0"/>
+              <a:rPr lang="en-US"/>
               <a:t>Click to edit Master text styles</a:t>
             </a:r>
           </a:p>
@@ -1569,38 +1571,37 @@
           <a:p>
             <a:pPr lvl="0"/>
             <a:r>
-              <a:rPr lang="en-US" smtClean="0"/>
+              <a:rPr lang="en-US"/>
               <a:t>Click to edit Master text styles</a:t>
             </a:r>
           </a:p>
           <a:p>
             <a:pPr lvl="1"/>
             <a:r>
-              <a:rPr lang="en-US" smtClean="0"/>
+              <a:rPr lang="en-US"/>
               <a:t>Second level</a:t>
             </a:r>
           </a:p>
           <a:p>
             <a:pPr lvl="2"/>
             <a:r>
-              <a:rPr lang="en-US" smtClean="0"/>
+              <a:rPr lang="en-US"/>
               <a:t>Third level</a:t>
             </a:r>
           </a:p>
           <a:p>
             <a:pPr lvl="3"/>
             <a:r>
-              <a:rPr lang="en-US" smtClean="0"/>
+              <a:rPr lang="en-US"/>
               <a:t>Fourth level</a:t>
             </a:r>
           </a:p>
           <a:p>
             <a:pPr lvl="4"/>
             <a:r>
-              <a:rPr lang="en-US" smtClean="0"/>
+              <a:rPr lang="en-US"/>
               <a:t>Fifth level</a:t>
             </a:r>
-            <a:endParaRPr lang="en-US"/>
           </a:p>
         </p:txBody>
       </p:sp>
@@ -1663,7 +1664,7 @@
           <a:p>
             <a:pPr lvl="0"/>
             <a:r>
-              <a:rPr lang="en-US" smtClean="0"/>
+              <a:rPr lang="en-US"/>
               <a:t>Click to edit Master text styles</a:t>
             </a:r>
           </a:p>
@@ -1719,38 +1720,37 @@
           <a:p>
             <a:pPr lvl="0"/>
             <a:r>
-              <a:rPr lang="en-US" smtClean="0"/>
+              <a:rPr lang="en-US"/>
               <a:t>Click to edit Master text styles</a:t>
             </a:r>
           </a:p>
           <a:p>
             <a:pPr lvl="1"/>
             <a:r>
-              <a:rPr lang="en-US" smtClean="0"/>
+              <a:rPr lang="en-US"/>
               <a:t>Second level</a:t>
             </a:r>
           </a:p>
           <a:p>
             <a:pPr lvl="2"/>
             <a:r>
-              <a:rPr lang="en-US" smtClean="0"/>
+              <a:rPr lang="en-US"/>
               <a:t>Third level</a:t>
             </a:r>
           </a:p>
           <a:p>
             <a:pPr lvl="3"/>
             <a:r>
-              <a:rPr lang="en-US" smtClean="0"/>
+              <a:rPr lang="en-US"/>
               <a:t>Fourth level</a:t>
             </a:r>
           </a:p>
           <a:p>
             <a:pPr lvl="4"/>
             <a:r>
-              <a:rPr lang="en-US" smtClean="0"/>
+              <a:rPr lang="en-US"/>
               <a:t>Fifth level</a:t>
             </a:r>
-            <a:endParaRPr lang="en-US"/>
           </a:p>
         </p:txBody>
       </p:sp>
@@ -1771,7 +1771,7 @@
           <a:p>
             <a:fld id="{5BCAD085-E8A6-8845-BD4E-CB4CCA059FC4}" type="datetimeFigureOut">
               <a:rPr lang="en-US" smtClean="0"/>
-              <a:t>1/27/13</a:t>
+              <a:t>3/18/2026</a:t>
             </a:fld>
             <a:endParaRPr lang="en-US"/>
           </a:p>
@@ -1865,10 +1865,9 @@
           <a:lstStyle/>
           <a:p>
             <a:r>
-              <a:rPr lang="en-US" smtClean="0"/>
+              <a:rPr lang="en-US"/>
               <a:t>Click to edit Master title style</a:t>
             </a:r>
-            <a:endParaRPr lang="en-US"/>
           </a:p>
         </p:txBody>
       </p:sp>
@@ -1889,7 +1888,7 @@
           <a:p>
             <a:fld id="{5BCAD085-E8A6-8845-BD4E-CB4CCA059FC4}" type="datetimeFigureOut">
               <a:rPr lang="en-US" smtClean="0"/>
-              <a:t>1/27/13</a:t>
+              <a:t>3/18/2026</a:t>
             </a:fld>
             <a:endParaRPr lang="en-US"/>
           </a:p>
@@ -1984,7 +1983,7 @@
           <a:p>
             <a:fld id="{5BCAD085-E8A6-8845-BD4E-CB4CCA059FC4}" type="datetimeFigureOut">
               <a:rPr lang="en-US" smtClean="0"/>
-              <a:t>1/27/13</a:t>
+              <a:t>3/18/2026</a:t>
             </a:fld>
             <a:endParaRPr lang="en-US"/>
           </a:p>
@@ -2087,10 +2086,9 @@
           </a:lstStyle>
           <a:p>
             <a:r>
-              <a:rPr lang="en-US" smtClean="0"/>
+              <a:rPr lang="en-US"/>
               <a:t>Click to edit Master title style</a:t>
             </a:r>
-            <a:endParaRPr lang="en-US"/>
           </a:p>
         </p:txBody>
       </p:sp>
@@ -2144,38 +2142,37 @@
           <a:p>
             <a:pPr lvl="0"/>
             <a:r>
-              <a:rPr lang="en-US" smtClean="0"/>
+              <a:rPr lang="en-US"/>
               <a:t>Click to edit Master text styles</a:t>
             </a:r>
           </a:p>
           <a:p>
             <a:pPr lvl="1"/>
             <a:r>
-              <a:rPr lang="en-US" smtClean="0"/>
+              <a:rPr lang="en-US"/>
               <a:t>Second level</a:t>
             </a:r>
           </a:p>
           <a:p>
             <a:pPr lvl="2"/>
             <a:r>
-              <a:rPr lang="en-US" smtClean="0"/>
+              <a:rPr lang="en-US"/>
               <a:t>Third level</a:t>
             </a:r>
           </a:p>
           <a:p>
             <a:pPr lvl="3"/>
             <a:r>
-              <a:rPr lang="en-US" smtClean="0"/>
+              <a:rPr lang="en-US"/>
               <a:t>Fourth level</a:t>
             </a:r>
           </a:p>
           <a:p>
             <a:pPr lvl="4"/>
             <a:r>
-              <a:rPr lang="en-US" smtClean="0"/>
+              <a:rPr lang="en-US"/>
               <a:t>Fifth level</a:t>
             </a:r>
-            <a:endParaRPr lang="en-US"/>
           </a:p>
         </p:txBody>
       </p:sp>
@@ -2238,7 +2235,7 @@
           <a:p>
             <a:pPr lvl="0"/>
             <a:r>
-              <a:rPr lang="en-US" smtClean="0"/>
+              <a:rPr lang="en-US"/>
               <a:t>Click to edit Master text styles</a:t>
             </a:r>
           </a:p>
@@ -2261,7 +2258,7 @@
           <a:p>
             <a:fld id="{5BCAD085-E8A6-8845-BD4E-CB4CCA059FC4}" type="datetimeFigureOut">
               <a:rPr lang="en-US" smtClean="0"/>
-              <a:t>1/27/13</a:t>
+              <a:t>3/18/2026</a:t>
             </a:fld>
             <a:endParaRPr lang="en-US"/>
           </a:p>
@@ -2364,10 +2361,9 @@
           </a:lstStyle>
           <a:p>
             <a:r>
-              <a:rPr lang="en-US" smtClean="0"/>
+              <a:rPr lang="en-US"/>
               <a:t>Click to edit Master title style</a:t>
             </a:r>
-            <a:endParaRPr lang="en-US"/>
           </a:p>
         </p:txBody>
       </p:sp>
@@ -2491,7 +2487,7 @@
           <a:p>
             <a:pPr lvl="0"/>
             <a:r>
-              <a:rPr lang="en-US" smtClean="0"/>
+              <a:rPr lang="en-US"/>
               <a:t>Click to edit Master text styles</a:t>
             </a:r>
           </a:p>
@@ -2514,7 +2510,7 @@
           <a:p>
             <a:fld id="{5BCAD085-E8A6-8845-BD4E-CB4CCA059FC4}" type="datetimeFigureOut">
               <a:rPr lang="en-US" smtClean="0"/>
-              <a:t>1/27/13</a:t>
+              <a:t>3/18/2026</a:t>
             </a:fld>
             <a:endParaRPr lang="en-US"/>
           </a:p>
@@ -2623,10 +2619,9 @@
           <a:lstStyle/>
           <a:p>
             <a:r>
-              <a:rPr lang="en-US" smtClean="0"/>
+              <a:rPr lang="en-US"/>
               <a:t>Click to edit Master title style</a:t>
             </a:r>
-            <a:endParaRPr lang="en-US"/>
           </a:p>
         </p:txBody>
       </p:sp>
@@ -2657,38 +2652,37 @@
           <a:p>
             <a:pPr lvl="0"/>
             <a:r>
-              <a:rPr lang="en-US" smtClean="0"/>
+              <a:rPr lang="en-US"/>
               <a:t>Click to edit Master text styles</a:t>
             </a:r>
           </a:p>
           <a:p>
             <a:pPr lvl="1"/>
             <a:r>
-              <a:rPr lang="en-US" smtClean="0"/>
+              <a:rPr lang="en-US"/>
               <a:t>Second level</a:t>
             </a:r>
           </a:p>
           <a:p>
             <a:pPr lvl="2"/>
             <a:r>
-              <a:rPr lang="en-US" smtClean="0"/>
+              <a:rPr lang="en-US"/>
               <a:t>Third level</a:t>
             </a:r>
           </a:p>
           <a:p>
             <a:pPr lvl="3"/>
             <a:r>
-              <a:rPr lang="en-US" smtClean="0"/>
+              <a:rPr lang="en-US"/>
               <a:t>Fourth level</a:t>
             </a:r>
           </a:p>
           <a:p>
             <a:pPr lvl="4"/>
             <a:r>
-              <a:rPr lang="en-US" smtClean="0"/>
+              <a:rPr lang="en-US"/>
               <a:t>Fifth level</a:t>
             </a:r>
-            <a:endParaRPr lang="en-US"/>
           </a:p>
         </p:txBody>
       </p:sp>
@@ -2727,7 +2721,7 @@
           <a:p>
             <a:fld id="{5BCAD085-E8A6-8845-BD4E-CB4CCA059FC4}" type="datetimeFigureOut">
               <a:rPr lang="en-US" smtClean="0"/>
-              <a:t>1/27/13</a:t>
+              <a:t>3/18/2026</a:t>
             </a:fld>
             <a:endParaRPr lang="en-US"/>
           </a:p>
@@ -3086,7 +3080,7 @@
 </file>
 
 <file path=ppt/slides/slide1.xml><?xml version="1.0" encoding="utf-8"?>
-<p:sld xmlns:a="http://schemas.openxmlformats.org/drawingml/2006/main" xmlns:p="http://schemas.openxmlformats.org/presentationml/2006/main" xmlns:r="http://schemas.openxmlformats.org/officeDocument/2006/relationships">
+<p:sld xmlns:a="http://schemas.openxmlformats.org/drawingml/2006/main" xmlns:r="http://schemas.openxmlformats.org/officeDocument/2006/relationships" xmlns:p="http://schemas.openxmlformats.org/presentationml/2006/main">
   <p:cSld>
     <p:bg>
       <p:bgPr>
@@ -3102,7 +3096,14 @@
         <p:cNvGrpSpPr/>
         <p:nvPr/>
       </p:nvGrpSpPr>
-      <p:grpSpPr/>
+      <p:grpSpPr>
+        <a:xfrm>
+          <a:off x="0" y="0"/>
+          <a:ext cx="0" cy="0"/>
+          <a:chOff x="0" y="0"/>
+          <a:chExt cx="0" cy="0"/>
+        </a:xfrm>
+      </p:grpSpPr>
       <p:sp>
         <p:nvSpPr>
           <p:cNvPr id="2" name="TextBox 1"/>
@@ -3214,7 +3215,7 @@
 </file>
 
 <file path=ppt/slides/slide2.xml><?xml version="1.0" encoding="utf-8"?>
-<p:sld xmlns:a="http://schemas.openxmlformats.org/drawingml/2006/main" xmlns:p="http://schemas.openxmlformats.org/presentationml/2006/main" xmlns:r="http://schemas.openxmlformats.org/officeDocument/2006/relationships">
+<p:sld xmlns:a="http://schemas.openxmlformats.org/drawingml/2006/main" xmlns:r="http://schemas.openxmlformats.org/officeDocument/2006/relationships" xmlns:p="http://schemas.openxmlformats.org/presentationml/2006/main">
   <p:cSld>
     <p:bg>
       <p:bgPr>
@@ -3230,7 +3231,14 @@
         <p:cNvGrpSpPr/>
         <p:nvPr/>
       </p:nvGrpSpPr>
-      <p:grpSpPr/>
+      <p:grpSpPr>
+        <a:xfrm>
+          <a:off x="0" y="0"/>
+          <a:ext cx="0" cy="0"/>
+          <a:chOff x="0" y="0"/>
+          <a:chExt cx="0" cy="0"/>
+        </a:xfrm>
+      </p:grpSpPr>
       <p:sp>
         <p:nvSpPr>
           <p:cNvPr id="2" name="Rectangle 1"/>
@@ -3271,6 +3279,7 @@
           <a:lstStyle/>
           <a:p>
             <a:pPr algn="ctr"/>
+            <a:endParaRPr/>
           </a:p>
         </p:txBody>
       </p:sp>
@@ -3317,7 +3326,7 @@
         <p:spPr>
           <a:xfrm>
             <a:off x="457200" y="1920240"/>
-            <a:ext cx="11247120" cy="4114800"/>
+            <a:ext cx="11247120" cy="3185487"/>
           </a:xfrm>
           <a:prstGeom prst="rect">
             <a:avLst/>
@@ -3339,7 +3348,7 @@
               </a:spcAft>
             </a:pPr>
             <a:r>
-              <a:rPr sz="1400">
+              <a:rPr sz="1400" dirty="0">
                 <a:solidFill>
                   <a:srgbClr val="616161"/>
                 </a:solidFill>
@@ -3357,7 +3366,7 @@
               </a:spcAft>
             </a:pPr>
             <a:r>
-              <a:rPr sz="1400">
+              <a:rPr sz="1400" dirty="0">
                 <a:solidFill>
                   <a:srgbClr val="616161"/>
                 </a:solidFill>
@@ -3375,7 +3384,7 @@
               </a:spcAft>
             </a:pPr>
             <a:r>
-              <a:rPr sz="1400">
+              <a:rPr sz="1400" dirty="0">
                 <a:solidFill>
                   <a:srgbClr val="616161"/>
                 </a:solidFill>
@@ -3393,7 +3402,7 @@
               </a:spcAft>
             </a:pPr>
             <a:r>
-              <a:rPr sz="1400">
+              <a:rPr sz="1400" dirty="0">
                 <a:solidFill>
                   <a:srgbClr val="616161"/>
                 </a:solidFill>
@@ -3411,7 +3420,7 @@
               </a:spcAft>
             </a:pPr>
             <a:r>
-              <a:rPr sz="1400">
+              <a:rPr sz="1400" dirty="0">
                 <a:solidFill>
                   <a:srgbClr val="616161"/>
                 </a:solidFill>
@@ -3429,7 +3438,7 @@
               </a:spcAft>
             </a:pPr>
             <a:r>
-              <a:rPr sz="1400">
+              <a:rPr sz="1400" dirty="0">
                 <a:solidFill>
                   <a:srgbClr val="616161"/>
                 </a:solidFill>
@@ -3446,14 +3455,11 @@
                 <a:spcPts val="200"/>
               </a:spcAft>
             </a:pPr>
-            <a:r>
-              <a:rPr sz="1400">
-                <a:solidFill>
-                  <a:srgbClr val="616161"/>
-                </a:solidFill>
-              </a:rPr>
-              <a:t>• </a:t>
-            </a:r>
+            <a:endParaRPr sz="1400" dirty="0">
+              <a:solidFill>
+                <a:srgbClr val="616161"/>
+              </a:solidFill>
+            </a:endParaRPr>
           </a:p>
           <a:p>
             <a:pPr>
@@ -3465,7 +3471,7 @@
               </a:spcAft>
             </a:pPr>
             <a:r>
-              <a:rPr sz="1400">
+              <a:rPr sz="1400" dirty="0">
                 <a:solidFill>
                   <a:srgbClr val="616161"/>
                 </a:solidFill>
@@ -3483,12 +3489,28 @@
               </a:spcAft>
             </a:pPr>
             <a:r>
-              <a:rPr sz="1300">
+              <a:rPr sz="1300" dirty="0">
                 <a:solidFill>
                   <a:srgbClr val="424242"/>
                 </a:solidFill>
               </a:rPr>
-              <a:t>    • Legally binding under eIDAS (EU), ESIGN Act (USA), and other global regulations.</a:t>
+              <a:t>    • Legally binding under </a:t>
+            </a:r>
+            <a:r>
+              <a:rPr sz="1300" dirty="0" err="1">
+                <a:solidFill>
+                  <a:srgbClr val="424242"/>
+                </a:solidFill>
+              </a:rPr>
+              <a:t>eIDAS</a:t>
+            </a:r>
+            <a:r>
+              <a:rPr sz="1300" dirty="0">
+                <a:solidFill>
+                  <a:srgbClr val="424242"/>
+                </a:solidFill>
+              </a:rPr>
+              <a:t> (EU), ESIGN Act (USA), and other global regulations.</a:t>
             </a:r>
           </a:p>
           <a:p>
@@ -3501,7 +3523,7 @@
               </a:spcAft>
             </a:pPr>
             <a:r>
-              <a:rPr sz="1300">
+              <a:rPr sz="1300" dirty="0">
                 <a:solidFill>
                   <a:srgbClr val="424242"/>
                 </a:solidFill>
@@ -3519,7 +3541,7 @@
               </a:spcAft>
             </a:pPr>
             <a:r>
-              <a:rPr sz="1300">
+              <a:rPr sz="1300" dirty="0">
                 <a:solidFill>
                   <a:srgbClr val="424242"/>
                 </a:solidFill>
@@ -3538,7 +3560,7 @@
 </file>
 
 <file path=ppt/slides/slide3.xml><?xml version="1.0" encoding="utf-8"?>
-<p:sld xmlns:a="http://schemas.openxmlformats.org/drawingml/2006/main" xmlns:p="http://schemas.openxmlformats.org/presentationml/2006/main" xmlns:r="http://schemas.openxmlformats.org/officeDocument/2006/relationships">
+<p:sld xmlns:a="http://schemas.openxmlformats.org/drawingml/2006/main" xmlns:r="http://schemas.openxmlformats.org/officeDocument/2006/relationships" xmlns:p="http://schemas.openxmlformats.org/presentationml/2006/main">
   <p:cSld>
     <p:bg>
       <p:bgPr>
@@ -3554,7 +3576,14 @@
         <p:cNvGrpSpPr/>
         <p:nvPr/>
       </p:nvGrpSpPr>
-      <p:grpSpPr/>
+      <p:grpSpPr>
+        <a:xfrm>
+          <a:off x="0" y="0"/>
+          <a:ext cx="0" cy="0"/>
+          <a:chOff x="0" y="0"/>
+          <a:chExt cx="0" cy="0"/>
+        </a:xfrm>
+      </p:grpSpPr>
       <p:sp>
         <p:nvSpPr>
           <p:cNvPr id="2" name="Rectangle 1"/>
@@ -3595,6 +3624,7 @@
           <a:lstStyle/>
           <a:p>
             <a:pPr algn="ctr"/>
+            <a:endParaRPr/>
           </a:p>
         </p:txBody>
       </p:sp>
@@ -3627,7 +3657,7 @@
                   <a:srgbClr val="FFFFFF"/>
                 </a:solidFill>
               </a:rPr>
-              <a:t>Adobe Sign — Author Role</a:t>
+              <a:t>Adobe Sign — Approver Role</a:t>
             </a:r>
           </a:p>
         </p:txBody>
@@ -3661,7 +3691,7 @@
                   <a:srgbClr val="616161"/>
                 </a:solidFill>
               </a:rPr>
-              <a:t>What does the Author experience?</a:t>
+              <a:t>What does the Approver experience?</a:t>
             </a:r>
           </a:p>
         </p:txBody>
@@ -3675,7 +3705,7 @@
         <p:spPr>
           <a:xfrm>
             <a:off x="457200" y="1920240"/>
-            <a:ext cx="11247120" cy="4114800"/>
+            <a:ext cx="11247120" cy="3662541"/>
           </a:xfrm>
           <a:prstGeom prst="rect">
             <a:avLst/>
@@ -3697,12 +3727,12 @@
               </a:spcAft>
             </a:pPr>
             <a:r>
-              <a:rPr sz="1400">
+              <a:rPr sz="1400" dirty="0">
                 <a:solidFill>
                   <a:srgbClr val="616161"/>
                 </a:solidFill>
               </a:rPr>
-              <a:t>• The Author creates the document and submits it for review.</a:t>
+              <a:t>• The Approver is the primary signer in the DMS Adobe Sign flow.</a:t>
             </a:r>
           </a:p>
           <a:p>
@@ -3714,14 +3744,11 @@
                 <a:spcPts val="200"/>
               </a:spcAft>
             </a:pPr>
-            <a:r>
-              <a:rPr sz="1400">
-                <a:solidFill>
-                  <a:srgbClr val="616161"/>
-                </a:solidFill>
-              </a:rPr>
-              <a:t>• The Author does NOT directly initiate the Adobe Sign process.</a:t>
-            </a:r>
+            <a:endParaRPr sz="1400">
+              <a:solidFill>
+                <a:srgbClr val="616161"/>
+              </a:solidFill>
+            </a:endParaRPr>
           </a:p>
           <a:p>
             <a:pPr>
@@ -3733,12 +3760,12 @@
               </a:spcAft>
             </a:pPr>
             <a:r>
-              <a:rPr sz="1400">
+              <a:rPr sz="1400" dirty="0">
                 <a:solidFill>
                   <a:srgbClr val="616161"/>
                 </a:solidFill>
               </a:rPr>
-              <a:t>• After the Approver approves, the Author may receive an Adobe Sign notification email if the workflow is configured to require a countersignature.</a:t>
+              <a:t>• Step-by-step experience:</a:t>
             </a:r>
           </a:p>
           <a:p>
@@ -3751,12 +3778,12 @@
               </a:spcAft>
             </a:pPr>
             <a:r>
-              <a:rPr sz="1400">
-                <a:solidFill>
-                  <a:srgbClr val="616161"/>
-                </a:solidFill>
-              </a:rPr>
-              <a:t>• </a:t>
+              <a:rPr sz="1300" dirty="0">
+                <a:solidFill>
+                  <a:srgbClr val="424242"/>
+                </a:solidFill>
+              </a:rPr>
+              <a:t>    • 1. Log in to SharePoint DMS.</a:t>
             </a:r>
           </a:p>
           <a:p>
@@ -3769,12 +3796,12 @@
               </a:spcAft>
             </a:pPr>
             <a:r>
-              <a:rPr sz="1400">
-                <a:solidFill>
-                  <a:srgbClr val="616161"/>
-                </a:solidFill>
-              </a:rPr>
-              <a:t>• If countersignature is required:</a:t>
+              <a:rPr sz="1300" dirty="0">
+                <a:solidFill>
+                  <a:srgbClr val="424242"/>
+                </a:solidFill>
+              </a:rPr>
+              <a:t>    • 2. Navigate to 'Assigned To Me' tab.</a:t>
             </a:r>
           </a:p>
           <a:p>
@@ -3787,12 +3814,12 @@
               </a:spcAft>
             </a:pPr>
             <a:r>
-              <a:rPr sz="1300">
+              <a:rPr sz="1300" dirty="0">
                 <a:solidFill>
                   <a:srgbClr val="424242"/>
                 </a:solidFill>
               </a:rPr>
-              <a:t>    • Open the Adobe Sign email and click 'Review and Sign'.</a:t>
+              <a:t>    • 3. Open the document with status 'In Review'.</a:t>
             </a:r>
           </a:p>
           <a:p>
@@ -3805,12 +3832,12 @@
               </a:spcAft>
             </a:pPr>
             <a:r>
-              <a:rPr sz="1300">
+              <a:rPr sz="1300" dirty="0">
                 <a:solidFill>
                   <a:srgbClr val="424242"/>
                 </a:solidFill>
               </a:rPr>
-              <a:t>    • The document opens in Adobe Sign. Review, then click to place your signature.</a:t>
+              <a:t>    • 4. Review the document in the inline viewer. Add comments if needed.</a:t>
             </a:r>
           </a:p>
           <a:p>
@@ -3823,12 +3850,12 @@
               </a:spcAft>
             </a:pPr>
             <a:r>
-              <a:rPr sz="1300">
+              <a:rPr sz="1300" dirty="0">
                 <a:solidFill>
                   <a:srgbClr val="424242"/>
                 </a:solidFill>
               </a:rPr>
-              <a:t>    • Click 'Click to Sign' to finalise.</a:t>
+              <a:t>    • 5. Click 'Approve' — status changes to 'Pending Approval' and Adobe Sign is initiated.</a:t>
             </a:r>
           </a:p>
           <a:p>
@@ -3841,12 +3868,12 @@
               </a:spcAft>
             </a:pPr>
             <a:r>
-              <a:rPr sz="1300">
+              <a:rPr sz="1300" dirty="0">
                 <a:solidFill>
                   <a:srgbClr val="424242"/>
                 </a:solidFill>
               </a:rPr>
-              <a:t>    • The document status updates to 'Signed' once all parties have signed.</a:t>
+              <a:t>    • 6. Receive an Adobe Sign email with a direct link to the document.</a:t>
             </a:r>
           </a:p>
           <a:p>
@@ -3859,12 +3886,12 @@
               </a:spcAft>
             </a:pPr>
             <a:r>
-              <a:rPr sz="1400">
-                <a:solidFill>
-                  <a:srgbClr val="616161"/>
-                </a:solidFill>
-              </a:rPr>
-              <a:t>• </a:t>
+              <a:rPr sz="1300" dirty="0">
+                <a:solidFill>
+                  <a:srgbClr val="424242"/>
+                </a:solidFill>
+              </a:rPr>
+              <a:t>    • 7. Click the link — the Adobe Sign interface opens in your browser.</a:t>
             </a:r>
           </a:p>
           <a:p>
@@ -3877,12 +3904,12 @@
               </a:spcAft>
             </a:pPr>
             <a:r>
-              <a:rPr sz="1400">
-                <a:solidFill>
-                  <a:srgbClr val="616161"/>
-                </a:solidFill>
-              </a:rPr>
-              <a:t>• If countersignature is NOT required:</a:t>
+              <a:rPr sz="1300" dirty="0">
+                <a:solidFill>
+                  <a:srgbClr val="424242"/>
+                </a:solidFill>
+              </a:rPr>
+              <a:t>    • 8. Review the document, then click the signature field. Type or draw your signature.</a:t>
             </a:r>
           </a:p>
           <a:p>
@@ -3895,12 +3922,12 @@
               </a:spcAft>
             </a:pPr>
             <a:r>
-              <a:rPr sz="1300">
+              <a:rPr sz="1300" dirty="0">
                 <a:solidFill>
                   <a:srgbClr val="424242"/>
                 </a:solidFill>
               </a:rPr>
-              <a:t>    • The Author's involvement ends at submission. The Approver handles the signature.</a:t>
+              <a:t>    • 9. Click 'Click to Sign'. Return to DMS and click 'Final Approve'.</a:t>
             </a:r>
           </a:p>
           <a:p>
@@ -3913,12 +3940,12 @@
               </a:spcAft>
             </a:pPr>
             <a:r>
-              <a:rPr sz="1300">
+              <a:rPr sz="1300" dirty="0">
                 <a:solidFill>
                   <a:srgbClr val="424242"/>
                 </a:solidFill>
               </a:rPr>
-              <a:t>    • The Author can track progress in 'My Documents' — the status badge updates automatically.</a:t>
+              <a:t>    • 10. Document status updates to 'Signed / Final / Approved'.</a:t>
             </a:r>
           </a:p>
         </p:txBody>
@@ -3932,7 +3959,7 @@
 </file>
 
 <file path=ppt/slides/slide4.xml><?xml version="1.0" encoding="utf-8"?>
-<p:sld xmlns:a="http://schemas.openxmlformats.org/drawingml/2006/main" xmlns:p="http://schemas.openxmlformats.org/presentationml/2006/main" xmlns:r="http://schemas.openxmlformats.org/officeDocument/2006/relationships">
+<p:sld xmlns:a="http://schemas.openxmlformats.org/drawingml/2006/main" xmlns:r="http://schemas.openxmlformats.org/officeDocument/2006/relationships" xmlns:p="http://schemas.openxmlformats.org/presentationml/2006/main">
   <p:cSld>
     <p:bg>
       <p:bgPr>
@@ -3948,7 +3975,14 @@
         <p:cNvGrpSpPr/>
         <p:nvPr/>
       </p:nvGrpSpPr>
-      <p:grpSpPr/>
+      <p:grpSpPr>
+        <a:xfrm>
+          <a:off x="0" y="0"/>
+          <a:ext cx="0" cy="0"/>
+          <a:chOff x="0" y="0"/>
+          <a:chExt cx="0" cy="0"/>
+        </a:xfrm>
+      </p:grpSpPr>
       <p:sp>
         <p:nvSpPr>
           <p:cNvPr id="2" name="Rectangle 1"/>
@@ -3989,6 +4023,7 @@
           <a:lstStyle/>
           <a:p>
             <a:pPr algn="ctr"/>
+            <a:endParaRPr/>
           </a:p>
         </p:txBody>
       </p:sp>
@@ -4021,7 +4056,7 @@
                   <a:srgbClr val="FFFFFF"/>
                 </a:solidFill>
               </a:rPr>
-              <a:t>Adobe Sign — Approver Role</a:t>
+              <a:t>Adobe Sign — Admin Role</a:t>
             </a:r>
           </a:p>
         </p:txBody>
@@ -4055,7 +4090,7 @@
                   <a:srgbClr val="616161"/>
                 </a:solidFill>
               </a:rPr>
-              <a:t>What does the Approver experience?</a:t>
+              <a:t>What does the Admin experience?</a:t>
             </a:r>
           </a:p>
         </p:txBody>
@@ -4096,7 +4131,7 @@
                   <a:srgbClr val="616161"/>
                 </a:solidFill>
               </a:rPr>
-              <a:t>• The Approver is the primary signer in the DMS Adobe Sign flow.</a:t>
+              <a:t>• Admins do not typically participate in the signature flow.</a:t>
             </a:r>
           </a:p>
           <a:p>
@@ -4132,7 +4167,7 @@
                   <a:srgbClr val="616161"/>
                 </a:solidFill>
               </a:rPr>
-              <a:t>• Step-by-step experience:</a:t>
+              <a:t>• Admin capabilities:</a:t>
             </a:r>
           </a:p>
           <a:p>
@@ -4150,7 +4185,7 @@
                   <a:srgbClr val="424242"/>
                 </a:solidFill>
               </a:rPr>
-              <a:t>    • 1. Log in to SharePoint DMS.</a:t>
+              <a:t>    • View the status of any document across all stages in 'All Documents'.</a:t>
             </a:r>
           </a:p>
           <a:p>
@@ -4168,7 +4203,7 @@
                   <a:srgbClr val="424242"/>
                 </a:solidFill>
               </a:rPr>
-              <a:t>    • 2. Navigate to 'Assigned To Me' tab.</a:t>
+              <a:t>    • Monitor signature status — look for 'Pending for Signature' or 'Signed' in the Status column.</a:t>
             </a:r>
           </a:p>
           <a:p>
@@ -4186,7 +4221,7 @@
                   <a:srgbClr val="424242"/>
                 </a:solidFill>
               </a:rPr>
-              <a:t>    • 3. Open the document with status 'In Review'.</a:t>
+              <a:t>    • Access the Signed Documents library in SharePoint to find all finalized PDF documents.</a:t>
             </a:r>
           </a:p>
           <a:p>
@@ -4204,7 +4239,7 @@
                   <a:srgbClr val="424242"/>
                 </a:solidFill>
               </a:rPr>
-              <a:t>    • 4. Review the document in the inline viewer. Add comments if needed.</a:t>
+              <a:t>    • Manage users and ensure Approvers are correctly assigned to the DMS Approvers group.</a:t>
             </a:r>
           </a:p>
           <a:p>
@@ -4217,12 +4252,12 @@
               </a:spcAft>
             </a:pPr>
             <a:r>
-              <a:rPr sz="1300">
-                <a:solidFill>
-                  <a:srgbClr val="424242"/>
-                </a:solidFill>
-              </a:rPr>
-              <a:t>    • 5. Click 'Approve' — status changes to 'Pending Approval' and Adobe Sign is initiated.</a:t>
+              <a:rPr sz="1400">
+                <a:solidFill>
+                  <a:srgbClr val="616161"/>
+                </a:solidFill>
+              </a:rPr>
+              <a:t>• </a:t>
             </a:r>
           </a:p>
           <a:p>
@@ -4235,12 +4270,12 @@
               </a:spcAft>
             </a:pPr>
             <a:r>
-              <a:rPr sz="1300">
-                <a:solidFill>
-                  <a:srgbClr val="424242"/>
-                </a:solidFill>
-              </a:rPr>
-              <a:t>    • 6. Receive an Adobe Sign email with a direct link to the document.</a:t>
+              <a:rPr sz="1400">
+                <a:solidFill>
+                  <a:srgbClr val="616161"/>
+                </a:solidFill>
+              </a:rPr>
+              <a:t>• Where to find signed documents:</a:t>
             </a:r>
           </a:p>
           <a:p>
@@ -4258,7 +4293,7 @@
                   <a:srgbClr val="424242"/>
                 </a:solidFill>
               </a:rPr>
-              <a:t>    • 7. Click the link — the Adobe Sign interface opens in your browser.</a:t>
+              <a:t>    • SharePoint Site → Signed Documents library (visible to Admin).</a:t>
             </a:r>
           </a:p>
           <a:p>
@@ -4276,7 +4311,7 @@
                   <a:srgbClr val="424242"/>
                 </a:solidFill>
               </a:rPr>
-              <a:t>    • 8. Review the document, then click the signature field. Type or draw your signature.</a:t>
+              <a:t>    • The signed PDF is automatically saved there once Adobe Sign confirms completion.</a:t>
             </a:r>
           </a:p>
           <a:p>
@@ -4294,25 +4329,7 @@
                   <a:srgbClr val="424242"/>
                 </a:solidFill>
               </a:rPr>
-              <a:t>    • 9. Click 'Click to Sign'. Return to DMS and click 'Final Approve'.</a:t>
-            </a:r>
-          </a:p>
-          <a:p>
-            <a:pPr>
-              <a:spcBef>
-                <a:spcPts val="400"/>
-              </a:spcBef>
-              <a:spcAft>
-                <a:spcPts val="200"/>
-              </a:spcAft>
-            </a:pPr>
-            <a:r>
-              <a:rPr sz="1300">
-                <a:solidFill>
-                  <a:srgbClr val="424242"/>
-                </a:solidFill>
-              </a:rPr>
-              <a:t>    • 10. Document status updates to 'Signed / Final / Approved'.</a:t>
+              <a:t>    • Document version is locked upon signing — no further edits are possible.</a:t>
             </a:r>
           </a:p>
         </p:txBody>
@@ -4326,7 +4343,7 @@
 </file>
 
 <file path=ppt/slides/slide5.xml><?xml version="1.0" encoding="utf-8"?>
-<p:sld xmlns:a="http://schemas.openxmlformats.org/drawingml/2006/main" xmlns:p="http://schemas.openxmlformats.org/presentationml/2006/main" xmlns:r="http://schemas.openxmlformats.org/officeDocument/2006/relationships">
+<p:sld xmlns:a="http://schemas.openxmlformats.org/drawingml/2006/main" xmlns:r="http://schemas.openxmlformats.org/officeDocument/2006/relationships" xmlns:p="http://schemas.openxmlformats.org/presentationml/2006/main">
   <p:cSld>
     <p:bg>
       <p:bgPr>
@@ -4342,7 +4359,14 @@
         <p:cNvGrpSpPr/>
         <p:nvPr/>
       </p:nvGrpSpPr>
-      <p:grpSpPr/>
+      <p:grpSpPr>
+        <a:xfrm>
+          <a:off x="0" y="0"/>
+          <a:ext cx="0" cy="0"/>
+          <a:chOff x="0" y="0"/>
+          <a:chExt cx="0" cy="0"/>
+        </a:xfrm>
+      </p:grpSpPr>
       <p:sp>
         <p:nvSpPr>
           <p:cNvPr id="2" name="Rectangle 1"/>
@@ -4383,6 +4407,7 @@
           <a:lstStyle/>
           <a:p>
             <a:pPr algn="ctr"/>
+            <a:endParaRPr/>
           </a:p>
         </p:txBody>
       </p:sp>
@@ -4415,7 +4440,7 @@
                   <a:srgbClr val="FFFFFF"/>
                 </a:solidFill>
               </a:rPr>
-              <a:t>Adobe Sign — Admin Role</a:t>
+              <a:t>How to Sign — Step-by-Step (Approver)</a:t>
             </a:r>
           </a:p>
         </p:txBody>
@@ -4449,21 +4474,65 @@
                   <a:srgbClr val="616161"/>
                 </a:solidFill>
               </a:rPr>
-              <a:t>What does the Admin experience?</a:t>
-            </a:r>
-          </a:p>
-        </p:txBody>
-      </p:sp>
-      <p:sp>
-        <p:nvSpPr>
-          <p:cNvPr id="5" name="TextBox 4"/>
+              <a:t>Screen flow from login to completed signature</a:t>
+            </a:r>
+          </a:p>
+        </p:txBody>
+      </p:sp>
+      <p:sp>
+        <p:nvSpPr>
+          <p:cNvPr id="5" name="Rectangle 4"/>
+          <p:cNvSpPr/>
+          <p:nvPr/>
+        </p:nvSpPr>
+        <p:spPr>
+          <a:xfrm>
+            <a:off x="457200" y="2011680"/>
+            <a:ext cx="2697480" cy="822960"/>
+          </a:xfrm>
+          <a:prstGeom prst="rect">
+            <a:avLst/>
+          </a:prstGeom>
+          <a:solidFill>
+            <a:srgbClr val="1A237E"/>
+          </a:solidFill>
+          <a:ln>
+            <a:noFill/>
+          </a:ln>
+        </p:spPr>
+        <p:style>
+          <a:lnRef idx="1">
+            <a:schemeClr val="accent1"/>
+          </a:lnRef>
+          <a:fillRef idx="3">
+            <a:schemeClr val="accent1"/>
+          </a:fillRef>
+          <a:effectRef idx="2">
+            <a:schemeClr val="accent1"/>
+          </a:effectRef>
+          <a:fontRef idx="minor">
+            <a:schemeClr val="lt1"/>
+          </a:fontRef>
+        </p:style>
+        <p:txBody>
+          <a:bodyPr rtlCol="0" anchor="ctr"/>
+          <a:lstStyle/>
+          <a:p>
+            <a:pPr algn="ctr"/>
+            <a:endParaRPr/>
+          </a:p>
+        </p:txBody>
+      </p:sp>
+      <p:sp>
+        <p:nvSpPr>
+          <p:cNvPr id="6" name="TextBox 5"/>
           <p:cNvSpPr txBox="1"/>
           <p:nvPr/>
         </p:nvSpPr>
         <p:spPr>
           <a:xfrm>
-            <a:off x="457200" y="1920240"/>
-            <a:ext cx="11247120" cy="4114800"/>
+            <a:off x="457200" y="2011680"/>
+            <a:ext cx="2697480" cy="822960"/>
           </a:xfrm>
           <a:prstGeom prst="rect">
             <a:avLst/>
@@ -4476,6 +4545,688 @@
           </a:bodyPr>
           <a:lstStyle/>
           <a:p>
+            <a:pPr algn="ctr"/>
+            <a:r>
+              <a:rPr sz="1100" b="1">
+                <a:solidFill>
+                  <a:srgbClr val="FFFFFF"/>
+                </a:solidFill>
+              </a:rPr>
+              <a:t>1. Log in to SharePoint DMS</a:t>
+            </a:r>
+          </a:p>
+        </p:txBody>
+      </p:sp>
+      <p:sp>
+        <p:nvSpPr>
+          <p:cNvPr id="7" name="TextBox 6"/>
+          <p:cNvSpPr txBox="1"/>
+          <p:nvPr/>
+        </p:nvSpPr>
+        <p:spPr>
+          <a:xfrm>
+            <a:off x="3063240" y="2148840"/>
+            <a:ext cx="228600" cy="457200"/>
+          </a:xfrm>
+          <a:prstGeom prst="rect">
+            <a:avLst/>
+          </a:prstGeom>
+          <a:noFill/>
+        </p:spPr>
+        <p:txBody>
+          <a:bodyPr wrap="square">
+            <a:spAutoFit/>
+          </a:bodyPr>
+          <a:lstStyle/>
+          <a:p>
+            <a:pPr algn="ctr"/>
+            <a:r>
+              <a:rPr sz="1400" b="1">
+                <a:solidFill>
+                  <a:srgbClr val="1A237E"/>
+                </a:solidFill>
+              </a:rPr>
+              <a:t>→</a:t>
+            </a:r>
+          </a:p>
+        </p:txBody>
+      </p:sp>
+      <p:sp>
+        <p:nvSpPr>
+          <p:cNvPr id="8" name="Rectangle 7"/>
+          <p:cNvSpPr/>
+          <p:nvPr/>
+        </p:nvSpPr>
+        <p:spPr>
+          <a:xfrm>
+            <a:off x="3200400" y="2011680"/>
+            <a:ext cx="2697480" cy="822960"/>
+          </a:xfrm>
+          <a:prstGeom prst="rect">
+            <a:avLst/>
+          </a:prstGeom>
+          <a:solidFill>
+            <a:srgbClr val="1565C0"/>
+          </a:solidFill>
+          <a:ln>
+            <a:noFill/>
+          </a:ln>
+        </p:spPr>
+        <p:style>
+          <a:lnRef idx="1">
+            <a:schemeClr val="accent1"/>
+          </a:lnRef>
+          <a:fillRef idx="3">
+            <a:schemeClr val="accent1"/>
+          </a:fillRef>
+          <a:effectRef idx="2">
+            <a:schemeClr val="accent1"/>
+          </a:effectRef>
+          <a:fontRef idx="minor">
+            <a:schemeClr val="lt1"/>
+          </a:fontRef>
+        </p:style>
+        <p:txBody>
+          <a:bodyPr rtlCol="0" anchor="ctr"/>
+          <a:lstStyle/>
+          <a:p>
+            <a:pPr algn="ctr"/>
+            <a:endParaRPr/>
+          </a:p>
+        </p:txBody>
+      </p:sp>
+      <p:sp>
+        <p:nvSpPr>
+          <p:cNvPr id="9" name="TextBox 8"/>
+          <p:cNvSpPr txBox="1"/>
+          <p:nvPr/>
+        </p:nvSpPr>
+        <p:spPr>
+          <a:xfrm>
+            <a:off x="3200400" y="2011680"/>
+            <a:ext cx="2697480" cy="822960"/>
+          </a:xfrm>
+          <a:prstGeom prst="rect">
+            <a:avLst/>
+          </a:prstGeom>
+          <a:noFill/>
+        </p:spPr>
+        <p:txBody>
+          <a:bodyPr wrap="square">
+            <a:spAutoFit/>
+          </a:bodyPr>
+          <a:lstStyle/>
+          <a:p>
+            <a:pPr algn="ctr"/>
+            <a:r>
+              <a:rPr sz="1100" b="1">
+                <a:solidFill>
+                  <a:srgbClr val="FFFFFF"/>
+                </a:solidFill>
+              </a:rPr>
+              <a:t>2. Open 'Assigned To Me'</a:t>
+            </a:r>
+          </a:p>
+        </p:txBody>
+      </p:sp>
+      <p:sp>
+        <p:nvSpPr>
+          <p:cNvPr id="10" name="TextBox 9"/>
+          <p:cNvSpPr txBox="1"/>
+          <p:nvPr/>
+        </p:nvSpPr>
+        <p:spPr>
+          <a:xfrm>
+            <a:off x="5806440" y="2148840"/>
+            <a:ext cx="228600" cy="457200"/>
+          </a:xfrm>
+          <a:prstGeom prst="rect">
+            <a:avLst/>
+          </a:prstGeom>
+          <a:noFill/>
+        </p:spPr>
+        <p:txBody>
+          <a:bodyPr wrap="square">
+            <a:spAutoFit/>
+          </a:bodyPr>
+          <a:lstStyle/>
+          <a:p>
+            <a:pPr algn="ctr"/>
+            <a:r>
+              <a:rPr sz="1400" b="1">
+                <a:solidFill>
+                  <a:srgbClr val="1A237E"/>
+                </a:solidFill>
+              </a:rPr>
+              <a:t>→</a:t>
+            </a:r>
+          </a:p>
+        </p:txBody>
+      </p:sp>
+      <p:sp>
+        <p:nvSpPr>
+          <p:cNvPr id="11" name="Rectangle 10"/>
+          <p:cNvSpPr/>
+          <p:nvPr/>
+        </p:nvSpPr>
+        <p:spPr>
+          <a:xfrm>
+            <a:off x="5943600" y="2011680"/>
+            <a:ext cx="2697480" cy="822960"/>
+          </a:xfrm>
+          <a:prstGeom prst="rect">
+            <a:avLst/>
+          </a:prstGeom>
+          <a:solidFill>
+            <a:srgbClr val="00796B"/>
+          </a:solidFill>
+          <a:ln>
+            <a:noFill/>
+          </a:ln>
+        </p:spPr>
+        <p:style>
+          <a:lnRef idx="1">
+            <a:schemeClr val="accent1"/>
+          </a:lnRef>
+          <a:fillRef idx="3">
+            <a:schemeClr val="accent1"/>
+          </a:fillRef>
+          <a:effectRef idx="2">
+            <a:schemeClr val="accent1"/>
+          </a:effectRef>
+          <a:fontRef idx="minor">
+            <a:schemeClr val="lt1"/>
+          </a:fontRef>
+        </p:style>
+        <p:txBody>
+          <a:bodyPr rtlCol="0" anchor="ctr"/>
+          <a:lstStyle/>
+          <a:p>
+            <a:pPr algn="ctr"/>
+            <a:endParaRPr/>
+          </a:p>
+        </p:txBody>
+      </p:sp>
+      <p:sp>
+        <p:nvSpPr>
+          <p:cNvPr id="12" name="TextBox 11"/>
+          <p:cNvSpPr txBox="1"/>
+          <p:nvPr/>
+        </p:nvSpPr>
+        <p:spPr>
+          <a:xfrm>
+            <a:off x="5943600" y="2011680"/>
+            <a:ext cx="2697480" cy="822960"/>
+          </a:xfrm>
+          <a:prstGeom prst="rect">
+            <a:avLst/>
+          </a:prstGeom>
+          <a:noFill/>
+        </p:spPr>
+        <p:txBody>
+          <a:bodyPr wrap="square">
+            <a:spAutoFit/>
+          </a:bodyPr>
+          <a:lstStyle/>
+          <a:p>
+            <a:pPr algn="ctr"/>
+            <a:r>
+              <a:rPr sz="1100" b="1">
+                <a:solidFill>
+                  <a:srgbClr val="FFFFFF"/>
+                </a:solidFill>
+              </a:rPr>
+              <a:t>3. Click Document</a:t>
+            </a:r>
+          </a:p>
+        </p:txBody>
+      </p:sp>
+      <p:sp>
+        <p:nvSpPr>
+          <p:cNvPr id="13" name="TextBox 12"/>
+          <p:cNvSpPr txBox="1"/>
+          <p:nvPr/>
+        </p:nvSpPr>
+        <p:spPr>
+          <a:xfrm>
+            <a:off x="8549640" y="2148840"/>
+            <a:ext cx="228600" cy="457200"/>
+          </a:xfrm>
+          <a:prstGeom prst="rect">
+            <a:avLst/>
+          </a:prstGeom>
+          <a:noFill/>
+        </p:spPr>
+        <p:txBody>
+          <a:bodyPr wrap="square">
+            <a:spAutoFit/>
+          </a:bodyPr>
+          <a:lstStyle/>
+          <a:p>
+            <a:pPr algn="ctr"/>
+            <a:r>
+              <a:rPr sz="1400" b="1">
+                <a:solidFill>
+                  <a:srgbClr val="1A237E"/>
+                </a:solidFill>
+              </a:rPr>
+              <a:t>→</a:t>
+            </a:r>
+          </a:p>
+        </p:txBody>
+      </p:sp>
+      <p:sp>
+        <p:nvSpPr>
+          <p:cNvPr id="14" name="Rectangle 13"/>
+          <p:cNvSpPr/>
+          <p:nvPr/>
+        </p:nvSpPr>
+        <p:spPr>
+          <a:xfrm>
+            <a:off x="8686800" y="2011680"/>
+            <a:ext cx="2697480" cy="822960"/>
+          </a:xfrm>
+          <a:prstGeom prst="rect">
+            <a:avLst/>
+          </a:prstGeom>
+          <a:solidFill>
+            <a:srgbClr val="E65100"/>
+          </a:solidFill>
+          <a:ln>
+            <a:noFill/>
+          </a:ln>
+        </p:spPr>
+        <p:style>
+          <a:lnRef idx="1">
+            <a:schemeClr val="accent1"/>
+          </a:lnRef>
+          <a:fillRef idx="3">
+            <a:schemeClr val="accent1"/>
+          </a:fillRef>
+          <a:effectRef idx="2">
+            <a:schemeClr val="accent1"/>
+          </a:effectRef>
+          <a:fontRef idx="minor">
+            <a:schemeClr val="lt1"/>
+          </a:fontRef>
+        </p:style>
+        <p:txBody>
+          <a:bodyPr rtlCol="0" anchor="ctr"/>
+          <a:lstStyle/>
+          <a:p>
+            <a:pPr algn="ctr"/>
+            <a:endParaRPr/>
+          </a:p>
+        </p:txBody>
+      </p:sp>
+      <p:sp>
+        <p:nvSpPr>
+          <p:cNvPr id="15" name="TextBox 14"/>
+          <p:cNvSpPr txBox="1"/>
+          <p:nvPr/>
+        </p:nvSpPr>
+        <p:spPr>
+          <a:xfrm>
+            <a:off x="8686800" y="2011680"/>
+            <a:ext cx="2697480" cy="822960"/>
+          </a:xfrm>
+          <a:prstGeom prst="rect">
+            <a:avLst/>
+          </a:prstGeom>
+          <a:noFill/>
+        </p:spPr>
+        <p:txBody>
+          <a:bodyPr wrap="square">
+            <a:spAutoFit/>
+          </a:bodyPr>
+          <a:lstStyle/>
+          <a:p>
+            <a:pPr algn="ctr"/>
+            <a:r>
+              <a:rPr sz="1100" b="1">
+                <a:solidFill>
+                  <a:srgbClr val="FFFFFF"/>
+                </a:solidFill>
+              </a:rPr>
+              <a:t>4. Click 'Approve'</a:t>
+            </a:r>
+          </a:p>
+        </p:txBody>
+      </p:sp>
+      <p:sp>
+        <p:nvSpPr>
+          <p:cNvPr id="16" name="Rectangle 15"/>
+          <p:cNvSpPr/>
+          <p:nvPr/>
+        </p:nvSpPr>
+        <p:spPr>
+          <a:xfrm>
+            <a:off x="457200" y="3108960"/>
+            <a:ext cx="2697480" cy="822960"/>
+          </a:xfrm>
+          <a:prstGeom prst="rect">
+            <a:avLst/>
+          </a:prstGeom>
+          <a:solidFill>
+            <a:srgbClr val="1A237E"/>
+          </a:solidFill>
+          <a:ln>
+            <a:noFill/>
+          </a:ln>
+        </p:spPr>
+        <p:style>
+          <a:lnRef idx="1">
+            <a:schemeClr val="accent1"/>
+          </a:lnRef>
+          <a:fillRef idx="3">
+            <a:schemeClr val="accent1"/>
+          </a:fillRef>
+          <a:effectRef idx="2">
+            <a:schemeClr val="accent1"/>
+          </a:effectRef>
+          <a:fontRef idx="minor">
+            <a:schemeClr val="lt1"/>
+          </a:fontRef>
+        </p:style>
+        <p:txBody>
+          <a:bodyPr rtlCol="0" anchor="ctr"/>
+          <a:lstStyle/>
+          <a:p>
+            <a:pPr algn="ctr"/>
+            <a:endParaRPr/>
+          </a:p>
+        </p:txBody>
+      </p:sp>
+      <p:sp>
+        <p:nvSpPr>
+          <p:cNvPr id="17" name="TextBox 16"/>
+          <p:cNvSpPr txBox="1"/>
+          <p:nvPr/>
+        </p:nvSpPr>
+        <p:spPr>
+          <a:xfrm>
+            <a:off x="457200" y="3108960"/>
+            <a:ext cx="2697480" cy="822960"/>
+          </a:xfrm>
+          <a:prstGeom prst="rect">
+            <a:avLst/>
+          </a:prstGeom>
+          <a:noFill/>
+        </p:spPr>
+        <p:txBody>
+          <a:bodyPr wrap="square">
+            <a:spAutoFit/>
+          </a:bodyPr>
+          <a:lstStyle/>
+          <a:p>
+            <a:pPr algn="ctr"/>
+            <a:r>
+              <a:rPr sz="1100" b="1">
+                <a:solidFill>
+                  <a:srgbClr val="FFFFFF"/>
+                </a:solidFill>
+              </a:rPr>
+              <a:t>5. Adobe Sign Email</a:t>
+            </a:r>
+          </a:p>
+        </p:txBody>
+      </p:sp>
+      <p:sp>
+        <p:nvSpPr>
+          <p:cNvPr id="18" name="Rectangle 17"/>
+          <p:cNvSpPr/>
+          <p:nvPr/>
+        </p:nvSpPr>
+        <p:spPr>
+          <a:xfrm>
+            <a:off x="3200400" y="3108960"/>
+            <a:ext cx="2697480" cy="822960"/>
+          </a:xfrm>
+          <a:prstGeom prst="rect">
+            <a:avLst/>
+          </a:prstGeom>
+          <a:solidFill>
+            <a:srgbClr val="1565C0"/>
+          </a:solidFill>
+          <a:ln>
+            <a:noFill/>
+          </a:ln>
+        </p:spPr>
+        <p:style>
+          <a:lnRef idx="1">
+            <a:schemeClr val="accent1"/>
+          </a:lnRef>
+          <a:fillRef idx="3">
+            <a:schemeClr val="accent1"/>
+          </a:fillRef>
+          <a:effectRef idx="2">
+            <a:schemeClr val="accent1"/>
+          </a:effectRef>
+          <a:fontRef idx="minor">
+            <a:schemeClr val="lt1"/>
+          </a:fontRef>
+        </p:style>
+        <p:txBody>
+          <a:bodyPr rtlCol="0" anchor="ctr"/>
+          <a:lstStyle/>
+          <a:p>
+            <a:pPr algn="ctr"/>
+            <a:endParaRPr/>
+          </a:p>
+        </p:txBody>
+      </p:sp>
+      <p:sp>
+        <p:nvSpPr>
+          <p:cNvPr id="19" name="TextBox 18"/>
+          <p:cNvSpPr txBox="1"/>
+          <p:nvPr/>
+        </p:nvSpPr>
+        <p:spPr>
+          <a:xfrm>
+            <a:off x="3200400" y="3108960"/>
+            <a:ext cx="2697480" cy="822960"/>
+          </a:xfrm>
+          <a:prstGeom prst="rect">
+            <a:avLst/>
+          </a:prstGeom>
+          <a:noFill/>
+        </p:spPr>
+        <p:txBody>
+          <a:bodyPr wrap="square">
+            <a:spAutoFit/>
+          </a:bodyPr>
+          <a:lstStyle/>
+          <a:p>
+            <a:pPr algn="ctr"/>
+            <a:r>
+              <a:rPr sz="1100" b="1">
+                <a:solidFill>
+                  <a:srgbClr val="FFFFFF"/>
+                </a:solidFill>
+              </a:rPr>
+              <a:t>6. Review &amp; Sign</a:t>
+            </a:r>
+          </a:p>
+        </p:txBody>
+      </p:sp>
+      <p:sp>
+        <p:nvSpPr>
+          <p:cNvPr id="20" name="Rectangle 19"/>
+          <p:cNvSpPr/>
+          <p:nvPr/>
+        </p:nvSpPr>
+        <p:spPr>
+          <a:xfrm>
+            <a:off x="5943600" y="3108960"/>
+            <a:ext cx="2697480" cy="822960"/>
+          </a:xfrm>
+          <a:prstGeom prst="rect">
+            <a:avLst/>
+          </a:prstGeom>
+          <a:solidFill>
+            <a:srgbClr val="00796B"/>
+          </a:solidFill>
+          <a:ln>
+            <a:noFill/>
+          </a:ln>
+        </p:spPr>
+        <p:style>
+          <a:lnRef idx="1">
+            <a:schemeClr val="accent1"/>
+          </a:lnRef>
+          <a:fillRef idx="3">
+            <a:schemeClr val="accent1"/>
+          </a:fillRef>
+          <a:effectRef idx="2">
+            <a:schemeClr val="accent1"/>
+          </a:effectRef>
+          <a:fontRef idx="minor">
+            <a:schemeClr val="lt1"/>
+          </a:fontRef>
+        </p:style>
+        <p:txBody>
+          <a:bodyPr rtlCol="0" anchor="ctr"/>
+          <a:lstStyle/>
+          <a:p>
+            <a:pPr algn="ctr"/>
+            <a:endParaRPr/>
+          </a:p>
+        </p:txBody>
+      </p:sp>
+      <p:sp>
+        <p:nvSpPr>
+          <p:cNvPr id="21" name="TextBox 20"/>
+          <p:cNvSpPr txBox="1"/>
+          <p:nvPr/>
+        </p:nvSpPr>
+        <p:spPr>
+          <a:xfrm>
+            <a:off x="5943600" y="3108960"/>
+            <a:ext cx="2697480" cy="822960"/>
+          </a:xfrm>
+          <a:prstGeom prst="rect">
+            <a:avLst/>
+          </a:prstGeom>
+          <a:noFill/>
+        </p:spPr>
+        <p:txBody>
+          <a:bodyPr wrap="square">
+            <a:spAutoFit/>
+          </a:bodyPr>
+          <a:lstStyle/>
+          <a:p>
+            <a:pPr algn="ctr"/>
+            <a:r>
+              <a:rPr sz="1100" b="1">
+                <a:solidFill>
+                  <a:srgbClr val="FFFFFF"/>
+                </a:solidFill>
+              </a:rPr>
+              <a:t>7. Click to Sign ✓</a:t>
+            </a:r>
+          </a:p>
+        </p:txBody>
+      </p:sp>
+      <p:sp>
+        <p:nvSpPr>
+          <p:cNvPr id="22" name="Rectangle 21"/>
+          <p:cNvSpPr/>
+          <p:nvPr/>
+        </p:nvSpPr>
+        <p:spPr>
+          <a:xfrm>
+            <a:off x="8686800" y="3108960"/>
+            <a:ext cx="2697480" cy="822960"/>
+          </a:xfrm>
+          <a:prstGeom prst="rect">
+            <a:avLst/>
+          </a:prstGeom>
+          <a:solidFill>
+            <a:srgbClr val="2E7D32"/>
+          </a:solidFill>
+          <a:ln>
+            <a:noFill/>
+          </a:ln>
+        </p:spPr>
+        <p:style>
+          <a:lnRef idx="1">
+            <a:schemeClr val="accent1"/>
+          </a:lnRef>
+          <a:fillRef idx="3">
+            <a:schemeClr val="accent1"/>
+          </a:fillRef>
+          <a:effectRef idx="2">
+            <a:schemeClr val="accent1"/>
+          </a:effectRef>
+          <a:fontRef idx="minor">
+            <a:schemeClr val="lt1"/>
+          </a:fontRef>
+        </p:style>
+        <p:txBody>
+          <a:bodyPr rtlCol="0" anchor="ctr"/>
+          <a:lstStyle/>
+          <a:p>
+            <a:pPr algn="ctr"/>
+            <a:endParaRPr/>
+          </a:p>
+        </p:txBody>
+      </p:sp>
+      <p:sp>
+        <p:nvSpPr>
+          <p:cNvPr id="23" name="TextBox 22"/>
+          <p:cNvSpPr txBox="1"/>
+          <p:nvPr/>
+        </p:nvSpPr>
+        <p:spPr>
+          <a:xfrm>
+            <a:off x="8686800" y="3108960"/>
+            <a:ext cx="2697480" cy="822960"/>
+          </a:xfrm>
+          <a:prstGeom prst="rect">
+            <a:avLst/>
+          </a:prstGeom>
+          <a:noFill/>
+        </p:spPr>
+        <p:txBody>
+          <a:bodyPr wrap="square">
+            <a:spAutoFit/>
+          </a:bodyPr>
+          <a:lstStyle/>
+          <a:p>
+            <a:pPr algn="ctr"/>
+            <a:r>
+              <a:rPr sz="1100" b="1">
+                <a:solidFill>
+                  <a:srgbClr val="FFFFFF"/>
+                </a:solidFill>
+              </a:rPr>
+              <a:t>8. Click 'Final Approve'</a:t>
+            </a:r>
+          </a:p>
+        </p:txBody>
+      </p:sp>
+      <p:sp>
+        <p:nvSpPr>
+          <p:cNvPr id="24" name="TextBox 23"/>
+          <p:cNvSpPr txBox="1"/>
+          <p:nvPr/>
+        </p:nvSpPr>
+        <p:spPr>
+          <a:xfrm>
+            <a:off x="457200" y="4206240"/>
+            <a:ext cx="11247120" cy="4114800"/>
+          </a:xfrm>
+          <a:prstGeom prst="rect">
+            <a:avLst/>
+          </a:prstGeom>
+          <a:noFill/>
+        </p:spPr>
+        <p:txBody>
+          <a:bodyPr wrap="square">
+            <a:spAutoFit/>
+          </a:bodyPr>
+          <a:lstStyle/>
+          <a:p>
             <a:pPr>
               <a:spcBef>
                 <a:spcPts val="400"/>
@@ -4485,12 +5236,12 @@
               </a:spcAft>
             </a:pPr>
             <a:r>
-              <a:rPr sz="1400">
+              <a:rPr sz="1300">
                 <a:solidFill>
                   <a:srgbClr val="616161"/>
                 </a:solidFill>
               </a:rPr>
-              <a:t>• Admins do not typically participate in the signature flow.</a:t>
+              <a:t>• Status Transitions during this flow:</a:t>
             </a:r>
           </a:p>
           <a:p>
@@ -4503,192 +5254,12 @@
               </a:spcAft>
             </a:pPr>
             <a:r>
-              <a:rPr sz="1400">
-                <a:solidFill>
-                  <a:srgbClr val="616161"/>
-                </a:solidFill>
-              </a:rPr>
-              <a:t>• </a:t>
-            </a:r>
-          </a:p>
-          <a:p>
-            <a:pPr>
-              <a:spcBef>
-                <a:spcPts val="400"/>
-              </a:spcBef>
-              <a:spcAft>
-                <a:spcPts val="200"/>
-              </a:spcAft>
-            </a:pPr>
-            <a:r>
-              <a:rPr sz="1400">
-                <a:solidFill>
-                  <a:srgbClr val="616161"/>
-                </a:solidFill>
-              </a:rPr>
-              <a:t>• Admin capabilities:</a:t>
-            </a:r>
-          </a:p>
-          <a:p>
-            <a:pPr>
-              <a:spcBef>
-                <a:spcPts val="400"/>
-              </a:spcBef>
-              <a:spcAft>
-                <a:spcPts val="200"/>
-              </a:spcAft>
-            </a:pPr>
-            <a:r>
-              <a:rPr sz="1300">
+              <a:rPr sz="1200">
                 <a:solidFill>
                   <a:srgbClr val="424242"/>
                 </a:solidFill>
               </a:rPr>
-              <a:t>    • View the status of any document across all stages in 'All Documents'.</a:t>
-            </a:r>
-          </a:p>
-          <a:p>
-            <a:pPr>
-              <a:spcBef>
-                <a:spcPts val="400"/>
-              </a:spcBef>
-              <a:spcAft>
-                <a:spcPts val="200"/>
-              </a:spcAft>
-            </a:pPr>
-            <a:r>
-              <a:rPr sz="1300">
-                <a:solidFill>
-                  <a:srgbClr val="424242"/>
-                </a:solidFill>
-              </a:rPr>
-              <a:t>    • Monitor signature status — look for 'Pending for Signature' or 'Signed' in the Status column.</a:t>
-            </a:r>
-          </a:p>
-          <a:p>
-            <a:pPr>
-              <a:spcBef>
-                <a:spcPts val="400"/>
-              </a:spcBef>
-              <a:spcAft>
-                <a:spcPts val="200"/>
-              </a:spcAft>
-            </a:pPr>
-            <a:r>
-              <a:rPr sz="1300">
-                <a:solidFill>
-                  <a:srgbClr val="424242"/>
-                </a:solidFill>
-              </a:rPr>
-              <a:t>    • Access the Signed Documents library in SharePoint to find all finalized PDF documents.</a:t>
-            </a:r>
-          </a:p>
-          <a:p>
-            <a:pPr>
-              <a:spcBef>
-                <a:spcPts val="400"/>
-              </a:spcBef>
-              <a:spcAft>
-                <a:spcPts val="200"/>
-              </a:spcAft>
-            </a:pPr>
-            <a:r>
-              <a:rPr sz="1300">
-                <a:solidFill>
-                  <a:srgbClr val="424242"/>
-                </a:solidFill>
-              </a:rPr>
-              <a:t>    • Manage users and ensure Approvers are correctly assigned to the DMS Approvers group.</a:t>
-            </a:r>
-          </a:p>
-          <a:p>
-            <a:pPr>
-              <a:spcBef>
-                <a:spcPts val="400"/>
-              </a:spcBef>
-              <a:spcAft>
-                <a:spcPts val="200"/>
-              </a:spcAft>
-            </a:pPr>
-            <a:r>
-              <a:rPr sz="1400">
-                <a:solidFill>
-                  <a:srgbClr val="616161"/>
-                </a:solidFill>
-              </a:rPr>
-              <a:t>• </a:t>
-            </a:r>
-          </a:p>
-          <a:p>
-            <a:pPr>
-              <a:spcBef>
-                <a:spcPts val="400"/>
-              </a:spcBef>
-              <a:spcAft>
-                <a:spcPts val="200"/>
-              </a:spcAft>
-            </a:pPr>
-            <a:r>
-              <a:rPr sz="1400">
-                <a:solidFill>
-                  <a:srgbClr val="616161"/>
-                </a:solidFill>
-              </a:rPr>
-              <a:t>• Where to find signed documents:</a:t>
-            </a:r>
-          </a:p>
-          <a:p>
-            <a:pPr>
-              <a:spcBef>
-                <a:spcPts val="400"/>
-              </a:spcBef>
-              <a:spcAft>
-                <a:spcPts val="200"/>
-              </a:spcAft>
-            </a:pPr>
-            <a:r>
-              <a:rPr sz="1300">
-                <a:solidFill>
-                  <a:srgbClr val="424242"/>
-                </a:solidFill>
-              </a:rPr>
-              <a:t>    • SharePoint Site → Signed Documents library (visible to Admin).</a:t>
-            </a:r>
-          </a:p>
-          <a:p>
-            <a:pPr>
-              <a:spcBef>
-                <a:spcPts val="400"/>
-              </a:spcBef>
-              <a:spcAft>
-                <a:spcPts val="200"/>
-              </a:spcAft>
-            </a:pPr>
-            <a:r>
-              <a:rPr sz="1300">
-                <a:solidFill>
-                  <a:srgbClr val="424242"/>
-                </a:solidFill>
-              </a:rPr>
-              <a:t>    • The signed PDF is automatically saved there once Adobe Sign confirms completion.</a:t>
-            </a:r>
-          </a:p>
-          <a:p>
-            <a:pPr>
-              <a:spcBef>
-                <a:spcPts val="400"/>
-              </a:spcBef>
-              <a:spcAft>
-                <a:spcPts val="200"/>
-              </a:spcAft>
-            </a:pPr>
-            <a:r>
-              <a:rPr sz="1300">
-                <a:solidFill>
-                  <a:srgbClr val="424242"/>
-                </a:solidFill>
-              </a:rPr>
-              <a:t>    • Document version is locked upon signing — no further edits are possible.</a:t>
+              <a:t>    • In Review → [Approve] → Pending Approval → [Adobe Sign] → Pending for Signature → [Final Approve] → Signed / Final</a:t>
             </a:r>
           </a:p>
         </p:txBody>
@@ -4702,7 +5273,7 @@
 </file>
 
 <file path=ppt/slides/slide6.xml><?xml version="1.0" encoding="utf-8"?>
-<p:sld xmlns:a="http://schemas.openxmlformats.org/drawingml/2006/main" xmlns:p="http://schemas.openxmlformats.org/presentationml/2006/main" xmlns:r="http://schemas.openxmlformats.org/officeDocument/2006/relationships">
+<p:sld xmlns:a="http://schemas.openxmlformats.org/drawingml/2006/main" xmlns:r="http://schemas.openxmlformats.org/officeDocument/2006/relationships" xmlns:p="http://schemas.openxmlformats.org/presentationml/2006/main">
   <p:cSld>
     <p:bg>
       <p:bgPr>
@@ -4718,7 +5289,14 @@
         <p:cNvGrpSpPr/>
         <p:nvPr/>
       </p:nvGrpSpPr>
-      <p:grpSpPr/>
+      <p:grpSpPr>
+        <a:xfrm>
+          <a:off x="0" y="0"/>
+          <a:ext cx="0" cy="0"/>
+          <a:chOff x="0" y="0"/>
+          <a:chExt cx="0" cy="0"/>
+        </a:xfrm>
+      </p:grpSpPr>
       <p:sp>
         <p:nvSpPr>
           <p:cNvPr id="2" name="Rectangle 1"/>
@@ -4759,6 +5337,7 @@
           <a:lstStyle/>
           <a:p>
             <a:pPr algn="ctr"/>
+            <a:endParaRPr/>
           </a:p>
         </p:txBody>
       </p:sp>
@@ -4791,7 +5370,7 @@
                   <a:srgbClr val="FFFFFF"/>
                 </a:solidFill>
               </a:rPr>
-              <a:t>How to Sign — Step-by-Step (Approver)</a:t>
+              <a:t>Signed Documents Library</a:t>
             </a:r>
           </a:p>
         </p:txBody>
@@ -4825,64 +5404,21 @@
                   <a:srgbClr val="616161"/>
                 </a:solidFill>
               </a:rPr>
-              <a:t>Screen flow from login to completed signature</a:t>
-            </a:r>
-          </a:p>
-        </p:txBody>
-      </p:sp>
-      <p:sp>
-        <p:nvSpPr>
-          <p:cNvPr id="5" name="Rectangle 4"/>
-          <p:cNvSpPr/>
-          <p:nvPr/>
-        </p:nvSpPr>
-        <p:spPr>
-          <a:xfrm>
-            <a:off x="457200" y="2011680"/>
-            <a:ext cx="2697480" cy="822960"/>
-          </a:xfrm>
-          <a:prstGeom prst="rect">
-            <a:avLst/>
-          </a:prstGeom>
-          <a:solidFill>
-            <a:srgbClr val="1A237E"/>
-          </a:solidFill>
-          <a:ln>
-            <a:noFill/>
-          </a:ln>
-        </p:spPr>
-        <p:style>
-          <a:lnRef idx="1">
-            <a:schemeClr val="accent1"/>
-          </a:lnRef>
-          <a:fillRef idx="3">
-            <a:schemeClr val="accent1"/>
-          </a:fillRef>
-          <a:effectRef idx="2">
-            <a:schemeClr val="accent1"/>
-          </a:effectRef>
-          <a:fontRef idx="minor">
-            <a:schemeClr val="lt1"/>
-          </a:fontRef>
-        </p:style>
-        <p:txBody>
-          <a:bodyPr rtlCol="0" anchor="ctr"/>
-          <a:lstStyle/>
-          <a:p>
-            <a:pPr algn="ctr"/>
-          </a:p>
-        </p:txBody>
-      </p:sp>
-      <p:sp>
-        <p:nvSpPr>
-          <p:cNvPr id="6" name="TextBox 5"/>
+              <a:t>Where to find finalized signed documents</a:t>
+            </a:r>
+          </a:p>
+        </p:txBody>
+      </p:sp>
+      <p:sp>
+        <p:nvSpPr>
+          <p:cNvPr id="5" name="TextBox 4"/>
           <p:cNvSpPr txBox="1"/>
           <p:nvPr/>
         </p:nvSpPr>
         <p:spPr>
           <a:xfrm>
-            <a:off x="457200" y="2011680"/>
-            <a:ext cx="2697480" cy="822960"/>
+            <a:off x="457200" y="1920240"/>
+            <a:ext cx="11247120" cy="4114800"/>
           </a:xfrm>
           <a:prstGeom prst="rect">
             <a:avLst/>
@@ -4895,681 +5431,6 @@
           </a:bodyPr>
           <a:lstStyle/>
           <a:p>
-            <a:pPr algn="ctr"/>
-            <a:r>
-              <a:rPr sz="1100" b="1">
-                <a:solidFill>
-                  <a:srgbClr val="FFFFFF"/>
-                </a:solidFill>
-              </a:rPr>
-              <a:t>1. Log in to SharePoint DMS</a:t>
-            </a:r>
-          </a:p>
-        </p:txBody>
-      </p:sp>
-      <p:sp>
-        <p:nvSpPr>
-          <p:cNvPr id="7" name="TextBox 6"/>
-          <p:cNvSpPr txBox="1"/>
-          <p:nvPr/>
-        </p:nvSpPr>
-        <p:spPr>
-          <a:xfrm>
-            <a:off x="3063240" y="2148840"/>
-            <a:ext cx="228600" cy="457200"/>
-          </a:xfrm>
-          <a:prstGeom prst="rect">
-            <a:avLst/>
-          </a:prstGeom>
-          <a:noFill/>
-        </p:spPr>
-        <p:txBody>
-          <a:bodyPr wrap="square">
-            <a:spAutoFit/>
-          </a:bodyPr>
-          <a:lstStyle/>
-          <a:p>
-            <a:pPr algn="ctr"/>
-            <a:r>
-              <a:rPr sz="1400" b="1">
-                <a:solidFill>
-                  <a:srgbClr val="1A237E"/>
-                </a:solidFill>
-              </a:rPr>
-              <a:t>→</a:t>
-            </a:r>
-          </a:p>
-        </p:txBody>
-      </p:sp>
-      <p:sp>
-        <p:nvSpPr>
-          <p:cNvPr id="8" name="Rectangle 7"/>
-          <p:cNvSpPr/>
-          <p:nvPr/>
-        </p:nvSpPr>
-        <p:spPr>
-          <a:xfrm>
-            <a:off x="3200400" y="2011680"/>
-            <a:ext cx="2697480" cy="822960"/>
-          </a:xfrm>
-          <a:prstGeom prst="rect">
-            <a:avLst/>
-          </a:prstGeom>
-          <a:solidFill>
-            <a:srgbClr val="1565C0"/>
-          </a:solidFill>
-          <a:ln>
-            <a:noFill/>
-          </a:ln>
-        </p:spPr>
-        <p:style>
-          <a:lnRef idx="1">
-            <a:schemeClr val="accent1"/>
-          </a:lnRef>
-          <a:fillRef idx="3">
-            <a:schemeClr val="accent1"/>
-          </a:fillRef>
-          <a:effectRef idx="2">
-            <a:schemeClr val="accent1"/>
-          </a:effectRef>
-          <a:fontRef idx="minor">
-            <a:schemeClr val="lt1"/>
-          </a:fontRef>
-        </p:style>
-        <p:txBody>
-          <a:bodyPr rtlCol="0" anchor="ctr"/>
-          <a:lstStyle/>
-          <a:p>
-            <a:pPr algn="ctr"/>
-          </a:p>
-        </p:txBody>
-      </p:sp>
-      <p:sp>
-        <p:nvSpPr>
-          <p:cNvPr id="9" name="TextBox 8"/>
-          <p:cNvSpPr txBox="1"/>
-          <p:nvPr/>
-        </p:nvSpPr>
-        <p:spPr>
-          <a:xfrm>
-            <a:off x="3200400" y="2011680"/>
-            <a:ext cx="2697480" cy="822960"/>
-          </a:xfrm>
-          <a:prstGeom prst="rect">
-            <a:avLst/>
-          </a:prstGeom>
-          <a:noFill/>
-        </p:spPr>
-        <p:txBody>
-          <a:bodyPr wrap="square">
-            <a:spAutoFit/>
-          </a:bodyPr>
-          <a:lstStyle/>
-          <a:p>
-            <a:pPr algn="ctr"/>
-            <a:r>
-              <a:rPr sz="1100" b="1">
-                <a:solidFill>
-                  <a:srgbClr val="FFFFFF"/>
-                </a:solidFill>
-              </a:rPr>
-              <a:t>2. Open 'Assigned To Me'</a:t>
-            </a:r>
-          </a:p>
-        </p:txBody>
-      </p:sp>
-      <p:sp>
-        <p:nvSpPr>
-          <p:cNvPr id="10" name="TextBox 9"/>
-          <p:cNvSpPr txBox="1"/>
-          <p:nvPr/>
-        </p:nvSpPr>
-        <p:spPr>
-          <a:xfrm>
-            <a:off x="5806440" y="2148840"/>
-            <a:ext cx="228600" cy="457200"/>
-          </a:xfrm>
-          <a:prstGeom prst="rect">
-            <a:avLst/>
-          </a:prstGeom>
-          <a:noFill/>
-        </p:spPr>
-        <p:txBody>
-          <a:bodyPr wrap="square">
-            <a:spAutoFit/>
-          </a:bodyPr>
-          <a:lstStyle/>
-          <a:p>
-            <a:pPr algn="ctr"/>
-            <a:r>
-              <a:rPr sz="1400" b="1">
-                <a:solidFill>
-                  <a:srgbClr val="1A237E"/>
-                </a:solidFill>
-              </a:rPr>
-              <a:t>→</a:t>
-            </a:r>
-          </a:p>
-        </p:txBody>
-      </p:sp>
-      <p:sp>
-        <p:nvSpPr>
-          <p:cNvPr id="11" name="Rectangle 10"/>
-          <p:cNvSpPr/>
-          <p:nvPr/>
-        </p:nvSpPr>
-        <p:spPr>
-          <a:xfrm>
-            <a:off x="5943600" y="2011680"/>
-            <a:ext cx="2697480" cy="822960"/>
-          </a:xfrm>
-          <a:prstGeom prst="rect">
-            <a:avLst/>
-          </a:prstGeom>
-          <a:solidFill>
-            <a:srgbClr val="00796B"/>
-          </a:solidFill>
-          <a:ln>
-            <a:noFill/>
-          </a:ln>
-        </p:spPr>
-        <p:style>
-          <a:lnRef idx="1">
-            <a:schemeClr val="accent1"/>
-          </a:lnRef>
-          <a:fillRef idx="3">
-            <a:schemeClr val="accent1"/>
-          </a:fillRef>
-          <a:effectRef idx="2">
-            <a:schemeClr val="accent1"/>
-          </a:effectRef>
-          <a:fontRef idx="minor">
-            <a:schemeClr val="lt1"/>
-          </a:fontRef>
-        </p:style>
-        <p:txBody>
-          <a:bodyPr rtlCol="0" anchor="ctr"/>
-          <a:lstStyle/>
-          <a:p>
-            <a:pPr algn="ctr"/>
-          </a:p>
-        </p:txBody>
-      </p:sp>
-      <p:sp>
-        <p:nvSpPr>
-          <p:cNvPr id="12" name="TextBox 11"/>
-          <p:cNvSpPr txBox="1"/>
-          <p:nvPr/>
-        </p:nvSpPr>
-        <p:spPr>
-          <a:xfrm>
-            <a:off x="5943600" y="2011680"/>
-            <a:ext cx="2697480" cy="822960"/>
-          </a:xfrm>
-          <a:prstGeom prst="rect">
-            <a:avLst/>
-          </a:prstGeom>
-          <a:noFill/>
-        </p:spPr>
-        <p:txBody>
-          <a:bodyPr wrap="square">
-            <a:spAutoFit/>
-          </a:bodyPr>
-          <a:lstStyle/>
-          <a:p>
-            <a:pPr algn="ctr"/>
-            <a:r>
-              <a:rPr sz="1100" b="1">
-                <a:solidFill>
-                  <a:srgbClr val="FFFFFF"/>
-                </a:solidFill>
-              </a:rPr>
-              <a:t>3. Click Document</a:t>
-            </a:r>
-          </a:p>
-        </p:txBody>
-      </p:sp>
-      <p:sp>
-        <p:nvSpPr>
-          <p:cNvPr id="13" name="TextBox 12"/>
-          <p:cNvSpPr txBox="1"/>
-          <p:nvPr/>
-        </p:nvSpPr>
-        <p:spPr>
-          <a:xfrm>
-            <a:off x="8549640" y="2148840"/>
-            <a:ext cx="228600" cy="457200"/>
-          </a:xfrm>
-          <a:prstGeom prst="rect">
-            <a:avLst/>
-          </a:prstGeom>
-          <a:noFill/>
-        </p:spPr>
-        <p:txBody>
-          <a:bodyPr wrap="square">
-            <a:spAutoFit/>
-          </a:bodyPr>
-          <a:lstStyle/>
-          <a:p>
-            <a:pPr algn="ctr"/>
-            <a:r>
-              <a:rPr sz="1400" b="1">
-                <a:solidFill>
-                  <a:srgbClr val="1A237E"/>
-                </a:solidFill>
-              </a:rPr>
-              <a:t>→</a:t>
-            </a:r>
-          </a:p>
-        </p:txBody>
-      </p:sp>
-      <p:sp>
-        <p:nvSpPr>
-          <p:cNvPr id="14" name="Rectangle 13"/>
-          <p:cNvSpPr/>
-          <p:nvPr/>
-        </p:nvSpPr>
-        <p:spPr>
-          <a:xfrm>
-            <a:off x="8686800" y="2011680"/>
-            <a:ext cx="2697480" cy="822960"/>
-          </a:xfrm>
-          <a:prstGeom prst="rect">
-            <a:avLst/>
-          </a:prstGeom>
-          <a:solidFill>
-            <a:srgbClr val="E65100"/>
-          </a:solidFill>
-          <a:ln>
-            <a:noFill/>
-          </a:ln>
-        </p:spPr>
-        <p:style>
-          <a:lnRef idx="1">
-            <a:schemeClr val="accent1"/>
-          </a:lnRef>
-          <a:fillRef idx="3">
-            <a:schemeClr val="accent1"/>
-          </a:fillRef>
-          <a:effectRef idx="2">
-            <a:schemeClr val="accent1"/>
-          </a:effectRef>
-          <a:fontRef idx="minor">
-            <a:schemeClr val="lt1"/>
-          </a:fontRef>
-        </p:style>
-        <p:txBody>
-          <a:bodyPr rtlCol="0" anchor="ctr"/>
-          <a:lstStyle/>
-          <a:p>
-            <a:pPr algn="ctr"/>
-          </a:p>
-        </p:txBody>
-      </p:sp>
-      <p:sp>
-        <p:nvSpPr>
-          <p:cNvPr id="15" name="TextBox 14"/>
-          <p:cNvSpPr txBox="1"/>
-          <p:nvPr/>
-        </p:nvSpPr>
-        <p:spPr>
-          <a:xfrm>
-            <a:off x="8686800" y="2011680"/>
-            <a:ext cx="2697480" cy="822960"/>
-          </a:xfrm>
-          <a:prstGeom prst="rect">
-            <a:avLst/>
-          </a:prstGeom>
-          <a:noFill/>
-        </p:spPr>
-        <p:txBody>
-          <a:bodyPr wrap="square">
-            <a:spAutoFit/>
-          </a:bodyPr>
-          <a:lstStyle/>
-          <a:p>
-            <a:pPr algn="ctr"/>
-            <a:r>
-              <a:rPr sz="1100" b="1">
-                <a:solidFill>
-                  <a:srgbClr val="FFFFFF"/>
-                </a:solidFill>
-              </a:rPr>
-              <a:t>4. Click 'Approve'</a:t>
-            </a:r>
-          </a:p>
-        </p:txBody>
-      </p:sp>
-      <p:sp>
-        <p:nvSpPr>
-          <p:cNvPr id="16" name="Rectangle 15"/>
-          <p:cNvSpPr/>
-          <p:nvPr/>
-        </p:nvSpPr>
-        <p:spPr>
-          <a:xfrm>
-            <a:off x="457200" y="3108960"/>
-            <a:ext cx="2697480" cy="822960"/>
-          </a:xfrm>
-          <a:prstGeom prst="rect">
-            <a:avLst/>
-          </a:prstGeom>
-          <a:solidFill>
-            <a:srgbClr val="1A237E"/>
-          </a:solidFill>
-          <a:ln>
-            <a:noFill/>
-          </a:ln>
-        </p:spPr>
-        <p:style>
-          <a:lnRef idx="1">
-            <a:schemeClr val="accent1"/>
-          </a:lnRef>
-          <a:fillRef idx="3">
-            <a:schemeClr val="accent1"/>
-          </a:fillRef>
-          <a:effectRef idx="2">
-            <a:schemeClr val="accent1"/>
-          </a:effectRef>
-          <a:fontRef idx="minor">
-            <a:schemeClr val="lt1"/>
-          </a:fontRef>
-        </p:style>
-        <p:txBody>
-          <a:bodyPr rtlCol="0" anchor="ctr"/>
-          <a:lstStyle/>
-          <a:p>
-            <a:pPr algn="ctr"/>
-          </a:p>
-        </p:txBody>
-      </p:sp>
-      <p:sp>
-        <p:nvSpPr>
-          <p:cNvPr id="17" name="TextBox 16"/>
-          <p:cNvSpPr txBox="1"/>
-          <p:nvPr/>
-        </p:nvSpPr>
-        <p:spPr>
-          <a:xfrm>
-            <a:off x="457200" y="3108960"/>
-            <a:ext cx="2697480" cy="822960"/>
-          </a:xfrm>
-          <a:prstGeom prst="rect">
-            <a:avLst/>
-          </a:prstGeom>
-          <a:noFill/>
-        </p:spPr>
-        <p:txBody>
-          <a:bodyPr wrap="square">
-            <a:spAutoFit/>
-          </a:bodyPr>
-          <a:lstStyle/>
-          <a:p>
-            <a:pPr algn="ctr"/>
-            <a:r>
-              <a:rPr sz="1100" b="1">
-                <a:solidFill>
-                  <a:srgbClr val="FFFFFF"/>
-                </a:solidFill>
-              </a:rPr>
-              <a:t>5. Adobe Sign Email</a:t>
-            </a:r>
-          </a:p>
-        </p:txBody>
-      </p:sp>
-      <p:sp>
-        <p:nvSpPr>
-          <p:cNvPr id="18" name="Rectangle 17"/>
-          <p:cNvSpPr/>
-          <p:nvPr/>
-        </p:nvSpPr>
-        <p:spPr>
-          <a:xfrm>
-            <a:off x="3200400" y="3108960"/>
-            <a:ext cx="2697480" cy="822960"/>
-          </a:xfrm>
-          <a:prstGeom prst="rect">
-            <a:avLst/>
-          </a:prstGeom>
-          <a:solidFill>
-            <a:srgbClr val="1565C0"/>
-          </a:solidFill>
-          <a:ln>
-            <a:noFill/>
-          </a:ln>
-        </p:spPr>
-        <p:style>
-          <a:lnRef idx="1">
-            <a:schemeClr val="accent1"/>
-          </a:lnRef>
-          <a:fillRef idx="3">
-            <a:schemeClr val="accent1"/>
-          </a:fillRef>
-          <a:effectRef idx="2">
-            <a:schemeClr val="accent1"/>
-          </a:effectRef>
-          <a:fontRef idx="minor">
-            <a:schemeClr val="lt1"/>
-          </a:fontRef>
-        </p:style>
-        <p:txBody>
-          <a:bodyPr rtlCol="0" anchor="ctr"/>
-          <a:lstStyle/>
-          <a:p>
-            <a:pPr algn="ctr"/>
-          </a:p>
-        </p:txBody>
-      </p:sp>
-      <p:sp>
-        <p:nvSpPr>
-          <p:cNvPr id="19" name="TextBox 18"/>
-          <p:cNvSpPr txBox="1"/>
-          <p:nvPr/>
-        </p:nvSpPr>
-        <p:spPr>
-          <a:xfrm>
-            <a:off x="3200400" y="3108960"/>
-            <a:ext cx="2697480" cy="822960"/>
-          </a:xfrm>
-          <a:prstGeom prst="rect">
-            <a:avLst/>
-          </a:prstGeom>
-          <a:noFill/>
-        </p:spPr>
-        <p:txBody>
-          <a:bodyPr wrap="square">
-            <a:spAutoFit/>
-          </a:bodyPr>
-          <a:lstStyle/>
-          <a:p>
-            <a:pPr algn="ctr"/>
-            <a:r>
-              <a:rPr sz="1100" b="1">
-                <a:solidFill>
-                  <a:srgbClr val="FFFFFF"/>
-                </a:solidFill>
-              </a:rPr>
-              <a:t>6. Review &amp; Sign</a:t>
-            </a:r>
-          </a:p>
-        </p:txBody>
-      </p:sp>
-      <p:sp>
-        <p:nvSpPr>
-          <p:cNvPr id="20" name="Rectangle 19"/>
-          <p:cNvSpPr/>
-          <p:nvPr/>
-        </p:nvSpPr>
-        <p:spPr>
-          <a:xfrm>
-            <a:off x="5943600" y="3108960"/>
-            <a:ext cx="2697480" cy="822960"/>
-          </a:xfrm>
-          <a:prstGeom prst="rect">
-            <a:avLst/>
-          </a:prstGeom>
-          <a:solidFill>
-            <a:srgbClr val="00796B"/>
-          </a:solidFill>
-          <a:ln>
-            <a:noFill/>
-          </a:ln>
-        </p:spPr>
-        <p:style>
-          <a:lnRef idx="1">
-            <a:schemeClr val="accent1"/>
-          </a:lnRef>
-          <a:fillRef idx="3">
-            <a:schemeClr val="accent1"/>
-          </a:fillRef>
-          <a:effectRef idx="2">
-            <a:schemeClr val="accent1"/>
-          </a:effectRef>
-          <a:fontRef idx="minor">
-            <a:schemeClr val="lt1"/>
-          </a:fontRef>
-        </p:style>
-        <p:txBody>
-          <a:bodyPr rtlCol="0" anchor="ctr"/>
-          <a:lstStyle/>
-          <a:p>
-            <a:pPr algn="ctr"/>
-          </a:p>
-        </p:txBody>
-      </p:sp>
-      <p:sp>
-        <p:nvSpPr>
-          <p:cNvPr id="21" name="TextBox 20"/>
-          <p:cNvSpPr txBox="1"/>
-          <p:nvPr/>
-        </p:nvSpPr>
-        <p:spPr>
-          <a:xfrm>
-            <a:off x="5943600" y="3108960"/>
-            <a:ext cx="2697480" cy="822960"/>
-          </a:xfrm>
-          <a:prstGeom prst="rect">
-            <a:avLst/>
-          </a:prstGeom>
-          <a:noFill/>
-        </p:spPr>
-        <p:txBody>
-          <a:bodyPr wrap="square">
-            <a:spAutoFit/>
-          </a:bodyPr>
-          <a:lstStyle/>
-          <a:p>
-            <a:pPr algn="ctr"/>
-            <a:r>
-              <a:rPr sz="1100" b="1">
-                <a:solidFill>
-                  <a:srgbClr val="FFFFFF"/>
-                </a:solidFill>
-              </a:rPr>
-              <a:t>7. Click to Sign ✓</a:t>
-            </a:r>
-          </a:p>
-        </p:txBody>
-      </p:sp>
-      <p:sp>
-        <p:nvSpPr>
-          <p:cNvPr id="22" name="Rectangle 21"/>
-          <p:cNvSpPr/>
-          <p:nvPr/>
-        </p:nvSpPr>
-        <p:spPr>
-          <a:xfrm>
-            <a:off x="8686800" y="3108960"/>
-            <a:ext cx="2697480" cy="822960"/>
-          </a:xfrm>
-          <a:prstGeom prst="rect">
-            <a:avLst/>
-          </a:prstGeom>
-          <a:solidFill>
-            <a:srgbClr val="2E7D32"/>
-          </a:solidFill>
-          <a:ln>
-            <a:noFill/>
-          </a:ln>
-        </p:spPr>
-        <p:style>
-          <a:lnRef idx="1">
-            <a:schemeClr val="accent1"/>
-          </a:lnRef>
-          <a:fillRef idx="3">
-            <a:schemeClr val="accent1"/>
-          </a:fillRef>
-          <a:effectRef idx="2">
-            <a:schemeClr val="accent1"/>
-          </a:effectRef>
-          <a:fontRef idx="minor">
-            <a:schemeClr val="lt1"/>
-          </a:fontRef>
-        </p:style>
-        <p:txBody>
-          <a:bodyPr rtlCol="0" anchor="ctr"/>
-          <a:lstStyle/>
-          <a:p>
-            <a:pPr algn="ctr"/>
-          </a:p>
-        </p:txBody>
-      </p:sp>
-      <p:sp>
-        <p:nvSpPr>
-          <p:cNvPr id="23" name="TextBox 22"/>
-          <p:cNvSpPr txBox="1"/>
-          <p:nvPr/>
-        </p:nvSpPr>
-        <p:spPr>
-          <a:xfrm>
-            <a:off x="8686800" y="3108960"/>
-            <a:ext cx="2697480" cy="822960"/>
-          </a:xfrm>
-          <a:prstGeom prst="rect">
-            <a:avLst/>
-          </a:prstGeom>
-          <a:noFill/>
-        </p:spPr>
-        <p:txBody>
-          <a:bodyPr wrap="square">
-            <a:spAutoFit/>
-          </a:bodyPr>
-          <a:lstStyle/>
-          <a:p>
-            <a:pPr algn="ctr"/>
-            <a:r>
-              <a:rPr sz="1100" b="1">
-                <a:solidFill>
-                  <a:srgbClr val="FFFFFF"/>
-                </a:solidFill>
-              </a:rPr>
-              <a:t>8. Click 'Final Approve'</a:t>
-            </a:r>
-          </a:p>
-        </p:txBody>
-      </p:sp>
-      <p:sp>
-        <p:nvSpPr>
-          <p:cNvPr id="24" name="TextBox 23"/>
-          <p:cNvSpPr txBox="1"/>
-          <p:nvPr/>
-        </p:nvSpPr>
-        <p:spPr>
-          <a:xfrm>
-            <a:off x="457200" y="4206240"/>
-            <a:ext cx="11247120" cy="4114800"/>
-          </a:xfrm>
-          <a:prstGeom prst="rect">
-            <a:avLst/>
-          </a:prstGeom>
-          <a:noFill/>
-        </p:spPr>
-        <p:txBody>
-          <a:bodyPr wrap="square">
-            <a:spAutoFit/>
-          </a:bodyPr>
-          <a:lstStyle/>
-          <a:p>
             <a:pPr>
               <a:spcBef>
                 <a:spcPts val="400"/>
@@ -5579,12 +5440,12 @@
               </a:spcAft>
             </a:pPr>
             <a:r>
-              <a:rPr sz="1300">
+              <a:rPr sz="1400">
                 <a:solidFill>
                   <a:srgbClr val="616161"/>
                 </a:solidFill>
               </a:rPr>
-              <a:t>• Status Transitions during this flow:</a:t>
+              <a:t>• Once a document is signed via Adobe Acrobat Sign:</a:t>
             </a:r>
           </a:p>
           <a:p>
@@ -5597,12 +5458,228 @@
               </a:spcAft>
             </a:pPr>
             <a:r>
-              <a:rPr sz="1200">
+              <a:rPr sz="1300">
                 <a:solidFill>
                   <a:srgbClr val="424242"/>
                 </a:solidFill>
               </a:rPr>
-              <a:t>    • In Review → [Approve] → Pending Approval → [Adobe Sign] → Pending for Signature → [Final Approve] → Signed / Final</a:t>
+              <a:t>    • The signed PDF is automatically retrieved and saved to the SharePoint 'Signed Documents' library.</a:t>
+            </a:r>
+          </a:p>
+          <a:p>
+            <a:pPr>
+              <a:spcBef>
+                <a:spcPts val="400"/>
+              </a:spcBef>
+              <a:spcAft>
+                <a:spcPts val="200"/>
+              </a:spcAft>
+            </a:pPr>
+            <a:r>
+              <a:rPr sz="1300">
+                <a:solidFill>
+                  <a:srgbClr val="424242"/>
+                </a:solidFill>
+              </a:rPr>
+              <a:t>    • The DMS document status is updated to 'Signed' or 'Final'.</a:t>
+            </a:r>
+          </a:p>
+          <a:p>
+            <a:pPr>
+              <a:spcBef>
+                <a:spcPts val="400"/>
+              </a:spcBef>
+              <a:spcAft>
+                <a:spcPts val="200"/>
+              </a:spcAft>
+            </a:pPr>
+            <a:r>
+              <a:rPr sz="1300">
+                <a:solidFill>
+                  <a:srgbClr val="424242"/>
+                </a:solidFill>
+              </a:rPr>
+              <a:t>    • The version is locked — no further edits can be made.</a:t>
+            </a:r>
+          </a:p>
+          <a:p>
+            <a:pPr>
+              <a:spcBef>
+                <a:spcPts val="400"/>
+              </a:spcBef>
+              <a:spcAft>
+                <a:spcPts val="200"/>
+              </a:spcAft>
+            </a:pPr>
+            <a:r>
+              <a:rPr sz="1400">
+                <a:solidFill>
+                  <a:srgbClr val="616161"/>
+                </a:solidFill>
+              </a:rPr>
+              <a:t>• </a:t>
+            </a:r>
+          </a:p>
+          <a:p>
+            <a:pPr>
+              <a:spcBef>
+                <a:spcPts val="400"/>
+              </a:spcBef>
+              <a:spcAft>
+                <a:spcPts val="200"/>
+              </a:spcAft>
+            </a:pPr>
+            <a:r>
+              <a:rPr sz="1400">
+                <a:solidFill>
+                  <a:srgbClr val="616161"/>
+                </a:solidFill>
+              </a:rPr>
+              <a:t>• How to access Signed Documents (Admin):</a:t>
+            </a:r>
+          </a:p>
+          <a:p>
+            <a:pPr>
+              <a:spcBef>
+                <a:spcPts val="400"/>
+              </a:spcBef>
+              <a:spcAft>
+                <a:spcPts val="200"/>
+              </a:spcAft>
+            </a:pPr>
+            <a:r>
+              <a:rPr sz="1300">
+                <a:solidFill>
+                  <a:srgbClr val="424242"/>
+                </a:solidFill>
+              </a:rPr>
+              <a:t>    • 1. Navigate to the SharePoint site.</a:t>
+            </a:r>
+          </a:p>
+          <a:p>
+            <a:pPr>
+              <a:spcBef>
+                <a:spcPts val="400"/>
+              </a:spcBef>
+              <a:spcAft>
+                <a:spcPts val="200"/>
+              </a:spcAft>
+            </a:pPr>
+            <a:r>
+              <a:rPr sz="1300">
+                <a:solidFill>
+                  <a:srgbClr val="424242"/>
+                </a:solidFill>
+              </a:rPr>
+              <a:t>    • 2. Open the 'Signed Documents' library from the site navigation or 'All Documents' → filter by 'Signed'.</a:t>
+            </a:r>
+          </a:p>
+          <a:p>
+            <a:pPr>
+              <a:spcBef>
+                <a:spcPts val="400"/>
+              </a:spcBef>
+              <a:spcAft>
+                <a:spcPts val="200"/>
+              </a:spcAft>
+            </a:pPr>
+            <a:r>
+              <a:rPr sz="1300">
+                <a:solidFill>
+                  <a:srgbClr val="424242"/>
+                </a:solidFill>
+              </a:rPr>
+              <a:t>    • 3. Each signed PDF has metadata: Drug, Category, Approver, Signed Date.</a:t>
+            </a:r>
+          </a:p>
+          <a:p>
+            <a:pPr>
+              <a:spcBef>
+                <a:spcPts val="400"/>
+              </a:spcBef>
+              <a:spcAft>
+                <a:spcPts val="200"/>
+              </a:spcAft>
+            </a:pPr>
+            <a:r>
+              <a:rPr sz="1400">
+                <a:solidFill>
+                  <a:srgbClr val="616161"/>
+                </a:solidFill>
+              </a:rPr>
+              <a:t>• </a:t>
+            </a:r>
+          </a:p>
+          <a:p>
+            <a:pPr>
+              <a:spcBef>
+                <a:spcPts val="400"/>
+              </a:spcBef>
+              <a:spcAft>
+                <a:spcPts val="200"/>
+              </a:spcAft>
+            </a:pPr>
+            <a:r>
+              <a:rPr sz="1400">
+                <a:solidFill>
+                  <a:srgbClr val="616161"/>
+                </a:solidFill>
+              </a:rPr>
+              <a:t>• Authors and Approvers:</a:t>
+            </a:r>
+          </a:p>
+          <a:p>
+            <a:pPr>
+              <a:spcBef>
+                <a:spcPts val="400"/>
+              </a:spcBef>
+              <a:spcAft>
+                <a:spcPts val="200"/>
+              </a:spcAft>
+            </a:pPr>
+            <a:r>
+              <a:rPr sz="1300">
+                <a:solidFill>
+                  <a:srgbClr val="424242"/>
+                </a:solidFill>
+              </a:rPr>
+              <a:t>    • Authors can see the 'Signed' status badge in 'My Documents'.</a:t>
+            </a:r>
+          </a:p>
+          <a:p>
+            <a:pPr>
+              <a:spcBef>
+                <a:spcPts val="400"/>
+              </a:spcBef>
+              <a:spcAft>
+                <a:spcPts val="200"/>
+              </a:spcAft>
+            </a:pPr>
+            <a:r>
+              <a:rPr sz="1300">
+                <a:solidFill>
+                  <a:srgbClr val="424242"/>
+                </a:solidFill>
+              </a:rPr>
+              <a:t>    • Approvers can see the 'Signed' status in documents they approved.</a:t>
+            </a:r>
+          </a:p>
+          <a:p>
+            <a:pPr>
+              <a:spcBef>
+                <a:spcPts val="400"/>
+              </a:spcBef>
+              <a:spcAft>
+                <a:spcPts val="200"/>
+              </a:spcAft>
+            </a:pPr>
+            <a:r>
+              <a:rPr sz="1300">
+                <a:solidFill>
+                  <a:srgbClr val="424242"/>
+                </a:solidFill>
+              </a:rPr>
+              <a:t>    • Neither role can edit or delete the signed version.</a:t>
             </a:r>
           </a:p>
         </p:txBody>
@@ -5616,7 +5693,7 @@
 </file>
 
 <file path=ppt/slides/slide7.xml><?xml version="1.0" encoding="utf-8"?>
-<p:sld xmlns:a="http://schemas.openxmlformats.org/drawingml/2006/main" xmlns:p="http://schemas.openxmlformats.org/presentationml/2006/main" xmlns:r="http://schemas.openxmlformats.org/officeDocument/2006/relationships">
+<p:sld xmlns:a="http://schemas.openxmlformats.org/drawingml/2006/main" xmlns:r="http://schemas.openxmlformats.org/officeDocument/2006/relationships" xmlns:p="http://schemas.openxmlformats.org/presentationml/2006/main">
   <p:cSld>
     <p:bg>
       <p:bgPr>
@@ -5632,7 +5709,14 @@
         <p:cNvGrpSpPr/>
         <p:nvPr/>
       </p:nvGrpSpPr>
-      <p:grpSpPr/>
+      <p:grpSpPr>
+        <a:xfrm>
+          <a:off x="0" y="0"/>
+          <a:ext cx="0" cy="0"/>
+          <a:chOff x="0" y="0"/>
+          <a:chExt cx="0" cy="0"/>
+        </a:xfrm>
+      </p:grpSpPr>
       <p:sp>
         <p:nvSpPr>
           <p:cNvPr id="2" name="Rectangle 1"/>
@@ -5673,418 +5757,7 @@
           <a:lstStyle/>
           <a:p>
             <a:pPr algn="ctr"/>
-          </a:p>
-        </p:txBody>
-      </p:sp>
-      <p:sp>
-        <p:nvSpPr>
-          <p:cNvPr id="3" name="TextBox 2"/>
-          <p:cNvSpPr txBox="1"/>
-          <p:nvPr/>
-        </p:nvSpPr>
-        <p:spPr>
-          <a:xfrm>
-            <a:off x="365760" y="182880"/>
-            <a:ext cx="11430000" cy="1005840"/>
-          </a:xfrm>
-          <a:prstGeom prst="rect">
-            <a:avLst/>
-          </a:prstGeom>
-          <a:noFill/>
-        </p:spPr>
-        <p:txBody>
-          <a:bodyPr wrap="square">
-            <a:spAutoFit/>
-          </a:bodyPr>
-          <a:lstStyle/>
-          <a:p>
-            <a:pPr algn="l"/>
-            <a:r>
-              <a:rPr sz="3000" b="1">
-                <a:solidFill>
-                  <a:srgbClr val="FFFFFF"/>
-                </a:solidFill>
-              </a:rPr>
-              <a:t>Signed Documents Library</a:t>
-            </a:r>
-          </a:p>
-        </p:txBody>
-      </p:sp>
-      <p:sp>
-        <p:nvSpPr>
-          <p:cNvPr id="4" name="TextBox 3"/>
-          <p:cNvSpPr txBox="1"/>
-          <p:nvPr/>
-        </p:nvSpPr>
-        <p:spPr>
-          <a:xfrm>
-            <a:off x="365760" y="1463040"/>
-            <a:ext cx="11430000" cy="548640"/>
-          </a:xfrm>
-          <a:prstGeom prst="rect">
-            <a:avLst/>
-          </a:prstGeom>
-          <a:noFill/>
-        </p:spPr>
-        <p:txBody>
-          <a:bodyPr wrap="square">
-            <a:spAutoFit/>
-          </a:bodyPr>
-          <a:lstStyle/>
-          <a:p>
-            <a:pPr algn="l"/>
-            <a:r>
-              <a:rPr sz="1400" b="0">
-                <a:solidFill>
-                  <a:srgbClr val="616161"/>
-                </a:solidFill>
-              </a:rPr>
-              <a:t>Where to find finalized signed documents</a:t>
-            </a:r>
-          </a:p>
-        </p:txBody>
-      </p:sp>
-      <p:sp>
-        <p:nvSpPr>
-          <p:cNvPr id="5" name="TextBox 4"/>
-          <p:cNvSpPr txBox="1"/>
-          <p:nvPr/>
-        </p:nvSpPr>
-        <p:spPr>
-          <a:xfrm>
-            <a:off x="457200" y="1920240"/>
-            <a:ext cx="11247120" cy="4114800"/>
-          </a:xfrm>
-          <a:prstGeom prst="rect">
-            <a:avLst/>
-          </a:prstGeom>
-          <a:noFill/>
-        </p:spPr>
-        <p:txBody>
-          <a:bodyPr wrap="square">
-            <a:spAutoFit/>
-          </a:bodyPr>
-          <a:lstStyle/>
-          <a:p>
-            <a:pPr>
-              <a:spcBef>
-                <a:spcPts val="400"/>
-              </a:spcBef>
-              <a:spcAft>
-                <a:spcPts val="200"/>
-              </a:spcAft>
-            </a:pPr>
-            <a:r>
-              <a:rPr sz="1400">
-                <a:solidFill>
-                  <a:srgbClr val="616161"/>
-                </a:solidFill>
-              </a:rPr>
-              <a:t>• Once a document is signed via Adobe Acrobat Sign:</a:t>
-            </a:r>
-          </a:p>
-          <a:p>
-            <a:pPr>
-              <a:spcBef>
-                <a:spcPts val="400"/>
-              </a:spcBef>
-              <a:spcAft>
-                <a:spcPts val="200"/>
-              </a:spcAft>
-            </a:pPr>
-            <a:r>
-              <a:rPr sz="1300">
-                <a:solidFill>
-                  <a:srgbClr val="424242"/>
-                </a:solidFill>
-              </a:rPr>
-              <a:t>    • The signed PDF is automatically retrieved and saved to the SharePoint 'Signed Documents' library.</a:t>
-            </a:r>
-          </a:p>
-          <a:p>
-            <a:pPr>
-              <a:spcBef>
-                <a:spcPts val="400"/>
-              </a:spcBef>
-              <a:spcAft>
-                <a:spcPts val="200"/>
-              </a:spcAft>
-            </a:pPr>
-            <a:r>
-              <a:rPr sz="1300">
-                <a:solidFill>
-                  <a:srgbClr val="424242"/>
-                </a:solidFill>
-              </a:rPr>
-              <a:t>    • The DMS document status is updated to 'Signed' or 'Final'.</a:t>
-            </a:r>
-          </a:p>
-          <a:p>
-            <a:pPr>
-              <a:spcBef>
-                <a:spcPts val="400"/>
-              </a:spcBef>
-              <a:spcAft>
-                <a:spcPts val="200"/>
-              </a:spcAft>
-            </a:pPr>
-            <a:r>
-              <a:rPr sz="1300">
-                <a:solidFill>
-                  <a:srgbClr val="424242"/>
-                </a:solidFill>
-              </a:rPr>
-              <a:t>    • The version is locked — no further edits can be made.</a:t>
-            </a:r>
-          </a:p>
-          <a:p>
-            <a:pPr>
-              <a:spcBef>
-                <a:spcPts val="400"/>
-              </a:spcBef>
-              <a:spcAft>
-                <a:spcPts val="200"/>
-              </a:spcAft>
-            </a:pPr>
-            <a:r>
-              <a:rPr sz="1400">
-                <a:solidFill>
-                  <a:srgbClr val="616161"/>
-                </a:solidFill>
-              </a:rPr>
-              <a:t>• </a:t>
-            </a:r>
-          </a:p>
-          <a:p>
-            <a:pPr>
-              <a:spcBef>
-                <a:spcPts val="400"/>
-              </a:spcBef>
-              <a:spcAft>
-                <a:spcPts val="200"/>
-              </a:spcAft>
-            </a:pPr>
-            <a:r>
-              <a:rPr sz="1400">
-                <a:solidFill>
-                  <a:srgbClr val="616161"/>
-                </a:solidFill>
-              </a:rPr>
-              <a:t>• How to access Signed Documents (Admin):</a:t>
-            </a:r>
-          </a:p>
-          <a:p>
-            <a:pPr>
-              <a:spcBef>
-                <a:spcPts val="400"/>
-              </a:spcBef>
-              <a:spcAft>
-                <a:spcPts val="200"/>
-              </a:spcAft>
-            </a:pPr>
-            <a:r>
-              <a:rPr sz="1300">
-                <a:solidFill>
-                  <a:srgbClr val="424242"/>
-                </a:solidFill>
-              </a:rPr>
-              <a:t>    • 1. Navigate to the SharePoint site.</a:t>
-            </a:r>
-          </a:p>
-          <a:p>
-            <a:pPr>
-              <a:spcBef>
-                <a:spcPts val="400"/>
-              </a:spcBef>
-              <a:spcAft>
-                <a:spcPts val="200"/>
-              </a:spcAft>
-            </a:pPr>
-            <a:r>
-              <a:rPr sz="1300">
-                <a:solidFill>
-                  <a:srgbClr val="424242"/>
-                </a:solidFill>
-              </a:rPr>
-              <a:t>    • 2. Open the 'Signed Documents' library from the site navigation or 'All Documents' → filter by 'Signed'.</a:t>
-            </a:r>
-          </a:p>
-          <a:p>
-            <a:pPr>
-              <a:spcBef>
-                <a:spcPts val="400"/>
-              </a:spcBef>
-              <a:spcAft>
-                <a:spcPts val="200"/>
-              </a:spcAft>
-            </a:pPr>
-            <a:r>
-              <a:rPr sz="1300">
-                <a:solidFill>
-                  <a:srgbClr val="424242"/>
-                </a:solidFill>
-              </a:rPr>
-              <a:t>    • 3. Each signed PDF has metadata: Drug, Category, Approver, Signed Date.</a:t>
-            </a:r>
-          </a:p>
-          <a:p>
-            <a:pPr>
-              <a:spcBef>
-                <a:spcPts val="400"/>
-              </a:spcBef>
-              <a:spcAft>
-                <a:spcPts val="200"/>
-              </a:spcAft>
-            </a:pPr>
-            <a:r>
-              <a:rPr sz="1400">
-                <a:solidFill>
-                  <a:srgbClr val="616161"/>
-                </a:solidFill>
-              </a:rPr>
-              <a:t>• </a:t>
-            </a:r>
-          </a:p>
-          <a:p>
-            <a:pPr>
-              <a:spcBef>
-                <a:spcPts val="400"/>
-              </a:spcBef>
-              <a:spcAft>
-                <a:spcPts val="200"/>
-              </a:spcAft>
-            </a:pPr>
-            <a:r>
-              <a:rPr sz="1400">
-                <a:solidFill>
-                  <a:srgbClr val="616161"/>
-                </a:solidFill>
-              </a:rPr>
-              <a:t>• Authors and Approvers:</a:t>
-            </a:r>
-          </a:p>
-          <a:p>
-            <a:pPr>
-              <a:spcBef>
-                <a:spcPts val="400"/>
-              </a:spcBef>
-              <a:spcAft>
-                <a:spcPts val="200"/>
-              </a:spcAft>
-            </a:pPr>
-            <a:r>
-              <a:rPr sz="1300">
-                <a:solidFill>
-                  <a:srgbClr val="424242"/>
-                </a:solidFill>
-              </a:rPr>
-              <a:t>    • Authors can see the 'Signed' status badge in 'My Documents'.</a:t>
-            </a:r>
-          </a:p>
-          <a:p>
-            <a:pPr>
-              <a:spcBef>
-                <a:spcPts val="400"/>
-              </a:spcBef>
-              <a:spcAft>
-                <a:spcPts val="200"/>
-              </a:spcAft>
-            </a:pPr>
-            <a:r>
-              <a:rPr sz="1300">
-                <a:solidFill>
-                  <a:srgbClr val="424242"/>
-                </a:solidFill>
-              </a:rPr>
-              <a:t>    • Approvers can see the 'Signed' status in documents they approved.</a:t>
-            </a:r>
-          </a:p>
-          <a:p>
-            <a:pPr>
-              <a:spcBef>
-                <a:spcPts val="400"/>
-              </a:spcBef>
-              <a:spcAft>
-                <a:spcPts val="200"/>
-              </a:spcAft>
-            </a:pPr>
-            <a:r>
-              <a:rPr sz="1300">
-                <a:solidFill>
-                  <a:srgbClr val="424242"/>
-                </a:solidFill>
-              </a:rPr>
-              <a:t>    • Neither role can edit or delete the signed version.</a:t>
-            </a:r>
-          </a:p>
-        </p:txBody>
-      </p:sp>
-    </p:spTree>
-  </p:cSld>
-  <p:clrMapOvr>
-    <a:masterClrMapping/>
-  </p:clrMapOvr>
-</p:sld>
-</file>
-
-<file path=ppt/slides/slide8.xml><?xml version="1.0" encoding="utf-8"?>
-<p:sld xmlns:a="http://schemas.openxmlformats.org/drawingml/2006/main" xmlns:p="http://schemas.openxmlformats.org/presentationml/2006/main" xmlns:r="http://schemas.openxmlformats.org/officeDocument/2006/relationships">
-  <p:cSld>
-    <p:bg>
-      <p:bgPr>
-        <a:solidFill>
-          <a:srgbClr val="F0F4FF"/>
-        </a:solidFill>
-        <a:effectLst/>
-      </p:bgPr>
-    </p:bg>
-    <p:spTree>
-      <p:nvGrpSpPr>
-        <p:cNvPr id="1" name=""/>
-        <p:cNvGrpSpPr/>
-        <p:nvPr/>
-      </p:nvGrpSpPr>
-      <p:grpSpPr/>
-      <p:sp>
-        <p:nvSpPr>
-          <p:cNvPr id="2" name="Rectangle 1"/>
-          <p:cNvSpPr/>
-          <p:nvPr/>
-        </p:nvSpPr>
-        <p:spPr>
-          <a:xfrm>
-            <a:off x="0" y="0"/>
-            <a:ext cx="12188952" cy="1371600"/>
-          </a:xfrm>
-          <a:prstGeom prst="rect">
-            <a:avLst/>
-          </a:prstGeom>
-          <a:solidFill>
-            <a:srgbClr val="1A237E"/>
-          </a:solidFill>
-          <a:ln>
-            <a:noFill/>
-          </a:ln>
-        </p:spPr>
-        <p:style>
-          <a:lnRef idx="1">
-            <a:schemeClr val="accent1"/>
-          </a:lnRef>
-          <a:fillRef idx="3">
-            <a:schemeClr val="accent1"/>
-          </a:fillRef>
-          <a:effectRef idx="2">
-            <a:schemeClr val="accent1"/>
-          </a:effectRef>
-          <a:fontRef idx="minor">
-            <a:schemeClr val="lt1"/>
-          </a:fontRef>
-        </p:style>
-        <p:txBody>
-          <a:bodyPr rtlCol="0" anchor="ctr"/>
-          <a:lstStyle/>
-          <a:p>
-            <a:pPr algn="ctr"/>
+            <a:endParaRPr/>
           </a:p>
         </p:txBody>
       </p:sp>

</xml_diff>